<commit_message>
Actualiza presentación ejecutiva (Automatización PPT)
Co-Authored-By: Claude Opus 5.5 <noreply@anthropic.com>
</commit_message>
<xml_diff>
--- a/trabajos/mi-proceso/Automatización PPT.pptx
+++ b/trabajos/mi-proceso/Automatización PPT.pptx
@@ -4,6 +4,9 @@
   <p:sldMasterIdLst>
     <p:sldMasterId id="2147483648" r:id="rId1"/>
   </p:sldMasterIdLst>
+  <p:notesMasterIdLst>
+    <p:notesMasterId r:id="rId15"/>
+  </p:notesMasterIdLst>
   <p:sldIdLst>
     <p:sldId id="256" r:id="rId2"/>
     <p:sldId id="257" r:id="rId3"/>
@@ -19,10 +22,7 @@
     <p:sldId id="267" r:id="rId13"/>
     <p:sldId id="268" r:id="rId14"/>
   </p:sldIdLst>
-  <p:notesMasterIdLst>
-    <p:notesMasterId r:id="rId15"/>
-  </p:notesMasterIdLst>
-  <p:sldSz cx="9144000" cy="5143500"/>
+  <p:sldSz cx="9144000" cy="5143500" type="screen16x9"/>
   <p:notesSz cx="5143500" cy="9144000"/>
   <p:defaultTextStyle>
     <a:lvl1pPr marL="0" algn="l" defTabSz="914400" rtl="0" eaLnBrk="1" latinLnBrk="0" hangingPunct="1">
@@ -119,43 +119,43 @@
   <p:extLst>
     <p:ext uri="{521415D9-36F7-43E2-AB2F-B90AF26B5E84}">
       <p14:sectionLst xmlns:p14="http://schemas.microsoft.com/office/powerpoint/2010/main">
-        <p14:section name="Inicio" id="{7293d233-d3b5-740e-3b9a-99bbce574938}">
+        <p14:section name="Inicio" id="{7293D233-D3B5-740E-3B9A-99BBCE574938}">
           <p14:sldIdLst>
             <p14:sldId id="256"/>
           </p14:sldIdLst>
         </p14:section>
-        <p14:section name="Resumen" id="{90240a7e-98f2-405c-4624-0c2d29d7b190}">
+        <p14:section name="Resumen" id="{90240A7E-98F2-405C-4624-0C2D29D7B190}">
           <p14:sldIdLst>
             <p14:sldId id="257"/>
           </p14:sldIdLst>
         </p14:section>
-        <p14:section name="Diagnóstico" id="{317fed15-35ad-8f42-ac1e-de3111877dc0}">
+        <p14:section name="Diagnóstico" id="{317FED15-35AD-8F42-AC1E-DE3111877DC0}">
           <p14:sldIdLst>
             <p14:sldId id="258"/>
             <p14:sldId id="259"/>
           </p14:sldIdLst>
         </p14:section>
-        <p14:section name="Solución" id="{2061c743-1cc6-f68a-10ac-2b0e2895c3de}">
+        <p14:section name="Solución" id="{2061C743-1CC6-F68A-10AC-2B0E2895C3DE}">
           <p14:sldIdLst>
             <p14:sldId id="260"/>
             <p14:sldId id="261"/>
             <p14:sldId id="262"/>
           </p14:sldIdLst>
         </p14:section>
-        <p14:section name="Resultados" id="{1888c232-5e25-c33b-89dc-037bb5c58cc3}">
+        <p14:section name="Resultados" id="{1888C232-5E25-C33B-89DC-037BB5C58CC3}">
           <p14:sldIdLst>
             <p14:sldId id="263"/>
             <p14:sldId id="264"/>
             <p14:sldId id="265"/>
           </p14:sldIdLst>
         </p14:section>
-        <p14:section name="Avance" id="{5bd0d27b-2b65-6ea8-9fe1-b1a12dc0172d}">
+        <p14:section name="Avance" id="{5BD0D27B-2B65-6EA8-9FE1-B1A12DC0172D}">
           <p14:sldIdLst>
             <p14:sldId id="266"/>
             <p14:sldId id="267"/>
           </p14:sldIdLst>
         </p14:section>
-        <p14:section name="Cierre" id="{58768c20-dd89-e117-de77-56cb35d70fb6}">
+        <p14:section name="Cierre" id="{58768C20-DD89-E117-DE77-56CB35D70FB6}">
           <p14:sldIdLst>
             <p14:sldId id="268"/>
           </p14:sldIdLst>
@@ -170,9 +170,11 @@
 </file>
 
 <file path=ppt/charts/chart1.xml><?xml version="1.0" encoding="utf-8"?>
-<c:chartSpace xmlns:c="http://schemas.openxmlformats.org/drawingml/2006/chart" xmlns:a="http://schemas.openxmlformats.org/drawingml/2006/main" xmlns:r="http://schemas.openxmlformats.org/officeDocument/2006/relationships">
+<c:chartSpace xmlns:c="http://schemas.openxmlformats.org/drawingml/2006/chart" xmlns:a="http://schemas.openxmlformats.org/drawingml/2006/main" xmlns:r="http://schemas.openxmlformats.org/officeDocument/2006/relationships" xmlns:c16r2="http://schemas.microsoft.com/office/drawing/2015/06/chart">
   <c:date1904 val="0"/>
+  <c:lang val="es-ES"/>
   <c:roundedCorners val="1"/>
+  <c:style val="2"/>
   <c:chart>
     <c:title>
       <c:tx>
@@ -189,7 +191,7 @@
               </a:defRPr>
             </a:pPr>
             <a:r>
-              <a:rPr sz="1200" b="0" i="0" u="none" strike="noStrike">
+              <a:rPr lang="es-MX" sz="1200" b="0" i="0" u="none" strike="noStrike">
                 <a:solidFill>
                   <a:srgbClr val="0E3B43"/>
                 </a:solidFill>
@@ -200,7 +202,6 @@
           </a:p>
         </c:rich>
       </c:tx>
-      <c:layout/>
       <c:overlay val="0"/>
     </c:title>
     <c:autoTitleDeleted val="0"/>
@@ -233,18 +234,26 @@
           <c:invertIfNegative val="0"/>
           <c:dLbls>
             <c:numFmt formatCode="0.00" sourceLinked="0"/>
+            <c:spPr>
+              <a:noFill/>
+              <a:ln>
+                <a:noFill/>
+              </a:ln>
+              <a:effectLst/>
+            </c:spPr>
             <c:txPr>
               <a:bodyPr/>
               <a:lstStyle/>
               <a:p>
                 <a:pPr>
-                  <a:defRPr b="0" i="0" strike="noStrike" sz="1100" u="none">
+                  <a:defRPr sz="1100" b="0" i="0" u="none" strike="noStrike">
                     <a:solidFill>
                       <a:srgbClr val="1C2B2D"/>
                     </a:solidFill>
                     <a:latin typeface="+mn-lt"/>
                   </a:defRPr>
                 </a:pPr>
+                <a:endParaRPr lang="es-CO"/>
               </a:p>
             </c:txPr>
             <c:showLegendKey val="0"/>
@@ -254,31 +263,34 @@
             <c:showPercent val="0"/>
             <c:showBubbleSize val="0"/>
             <c:showLeaderLines val="0"/>
+            <c:extLst>
+              <c:ext xmlns:c15="http://schemas.microsoft.com/office/drawing/2012/chart" uri="{CE6537A1-D6FC-4f65-9D91-7224C49458BB}">
+                <c15:showLeaderLines val="0"/>
+              </c:ext>
+            </c:extLst>
           </c:dLbls>
           <c:cat>
-            <c:multiLvlStrRef>
+            <c:strRef>
               <c:f>Sheet1!$A$2:$A$6</c:f>
-              <c:multiLvlStrCache>
+              <c:strCache>
                 <c:ptCount val="5"/>
-                <c:lvl>
-                  <c:pt idx="0">
-                    <c:v>OPP-05 RPA para escaneo</c:v>
-                  </c:pt>
-                  <c:pt idx="1">
-                    <c:v>OPP-04 Recogida a domicilio</c:v>
-                  </c:pt>
-                  <c:pt idx="2">
-                    <c:v>OPP-03 Estado en la web</c:v>
-                  </c:pt>
-                  <c:pt idx="3">
-                    <c:v>OPP-01 Portal de carga</c:v>
-                  </c:pt>
-                  <c:pt idx="4">
-                    <c:v>OPP-02 Validación automática</c:v>
-                  </c:pt>
-                </c:lvl>
-              </c:multiLvlStrCache>
-            </c:multiLvlStrRef>
+                <c:pt idx="0">
+                  <c:v>OPP-05 RPA para escaneo</c:v>
+                </c:pt>
+                <c:pt idx="1">
+                  <c:v>OPP-04 Recogida a domicilio</c:v>
+                </c:pt>
+                <c:pt idx="2">
+                  <c:v>OPP-03 Estado en la web</c:v>
+                </c:pt>
+                <c:pt idx="3">
+                  <c:v>OPP-01 Portal de carga</c:v>
+                </c:pt>
+                <c:pt idx="4">
+                  <c:v>OPP-02 Validación automática</c:v>
+                </c:pt>
+              </c:strCache>
+            </c:strRef>
           </c:cat>
           <c:val>
             <c:numRef>
@@ -304,36 +316,23 @@
               </c:numCache>
             </c:numRef>
           </c:val>
+          <c:extLst>
+            <c:ext xmlns:c16="http://schemas.microsoft.com/office/drawing/2014/chart" uri="{C3380CC4-5D6E-409C-BE32-E72D297353CC}">
+              <c16:uniqueId val="{00000000-3BC6-43A9-BE18-842652A4B8E0}"/>
+            </c:ext>
+          </c:extLst>
         </c:ser>
         <c:dLbls>
-          <c:numFmt formatCode="0.00" sourceLinked="0"/>
-          <c:txPr>
-            <a:bodyPr/>
-            <a:lstStyle/>
-            <a:p>
-              <a:pPr>
-                <a:defRPr b="0" i="0" strike="noStrike" sz="1100" u="none">
-                  <a:solidFill>
-                    <a:srgbClr val="1C2B2D"/>
-                  </a:solidFill>
-                  <a:latin typeface="+mn-lt"/>
-                </a:defRPr>
-              </a:pPr>
-            </a:p>
-          </c:txPr>
           <c:showLegendKey val="0"/>
           <c:showVal val="1"/>
           <c:showCatName val="0"/>
           <c:showSerName val="0"/>
           <c:showPercent val="0"/>
           <c:showBubbleSize val="0"/>
-          <c:showLeaderLines val="0"/>
         </c:dLbls>
         <c:gapWidth val="60"/>
-        <c:overlap val="0"/>
         <c:axId val="2094734554"/>
         <c:axId val="2094734552"/>
-        <c:axId val="2094734556"/>
       </c:barChart>
       <c:catAx>
         <c:axId val="2094734554"/>
@@ -374,6 +373,7 @@
         <c:crosses val="autoZero"/>
         <c:auto val="1"/>
         <c:lblAlgn val="ctr"/>
+        <c:lblOffset val="100"/>
         <c:noMultiLvlLbl val="1"/>
       </c:catAx>
       <c:valAx>
@@ -439,6 +439,7 @@
     </c:plotArea>
     <c:plotVisOnly val="1"/>
     <c:dispBlanksAs val="span"/>
+    <c:showDLblsOverMax val="1"/>
   </c:chart>
   <c:spPr>
     <a:noFill/>
@@ -454,9 +455,11 @@
 </file>
 
 <file path=ppt/charts/chart2.xml><?xml version="1.0" encoding="utf-8"?>
-<c:chartSpace xmlns:c="http://schemas.openxmlformats.org/drawingml/2006/chart" xmlns:a="http://schemas.openxmlformats.org/drawingml/2006/main" xmlns:r="http://schemas.openxmlformats.org/officeDocument/2006/relationships">
+<c:chartSpace xmlns:c="http://schemas.openxmlformats.org/drawingml/2006/chart" xmlns:a="http://schemas.openxmlformats.org/drawingml/2006/main" xmlns:r="http://schemas.openxmlformats.org/officeDocument/2006/relationships" xmlns:c16r2="http://schemas.microsoft.com/office/drawing/2015/06/chart">
   <c:date1904 val="0"/>
+  <c:lang val="es-ES"/>
   <c:roundedCorners val="1"/>
+  <c:style val="2"/>
   <c:chart>
     <c:title>
       <c:tx>
@@ -473,7 +476,7 @@
               </a:defRPr>
             </a:pPr>
             <a:r>
-              <a:rPr sz="1200" b="0" i="0" u="none" strike="noStrike">
+              <a:rPr lang="es-MX" sz="1200" b="0" i="0" u="none" strike="noStrike">
                 <a:solidFill>
                   <a:srgbClr val="0E3B43"/>
                 </a:solidFill>
@@ -484,7 +487,6 @@
           </a:p>
         </c:rich>
       </c:tx>
-      <c:layout/>
       <c:overlay val="0"/>
     </c:title>
     <c:autoTitleDeleted val="0"/>
@@ -515,30 +517,6 @@
             <a:effectLst/>
           </c:spPr>
           <c:invertIfNegative val="0"/>
-          <c:dLbls>
-            <c:numFmt formatCode="#,##0" sourceLinked="0"/>
-            <c:txPr>
-              <a:bodyPr/>
-              <a:lstStyle/>
-              <a:p>
-                <a:pPr>
-                  <a:defRPr b="0" i="0" strike="noStrike" sz="1100" u="none">
-                    <a:solidFill>
-                      <a:srgbClr val="1C2B2D"/>
-                    </a:solidFill>
-                    <a:latin typeface="+mn-lt"/>
-                  </a:defRPr>
-                </a:pPr>
-              </a:p>
-            </c:txPr>
-            <c:showLegendKey val="0"/>
-            <c:showVal val="1"/>
-            <c:showCatName val="0"/>
-            <c:showSerName val="0"/>
-            <c:showPercent val="0"/>
-            <c:showBubbleSize val="0"/>
-            <c:showLeaderLines val="0"/>
-          </c:dLbls>
           <c:dPt>
             <c:idx val="0"/>
             <c:invertIfNegative val="0"/>
@@ -549,6 +527,11 @@
               </a:solidFill>
               <a:effectLst/>
             </c:spPr>
+            <c:extLst>
+              <c:ext xmlns:c16="http://schemas.microsoft.com/office/drawing/2014/chart" uri="{C3380CC4-5D6E-409C-BE32-E72D297353CC}">
+                <c16:uniqueId val="{00000001-0F02-45FD-855C-7F1A26713155}"/>
+              </c:ext>
+            </c:extLst>
           </c:dPt>
           <c:dPt>
             <c:idx val="1"/>
@@ -560,6 +543,11 @@
               </a:solidFill>
               <a:effectLst/>
             </c:spPr>
+            <c:extLst>
+              <c:ext xmlns:c16="http://schemas.microsoft.com/office/drawing/2014/chart" uri="{C3380CC4-5D6E-409C-BE32-E72D297353CC}">
+                <c16:uniqueId val="{00000003-0F02-45FD-855C-7F1A26713155}"/>
+              </c:ext>
+            </c:extLst>
           </c:dPt>
           <c:dPt>
             <c:idx val="2"/>
@@ -571,25 +559,65 @@
               </a:solidFill>
               <a:effectLst/>
             </c:spPr>
+            <c:extLst>
+              <c:ext xmlns:c16="http://schemas.microsoft.com/office/drawing/2014/chart" uri="{C3380CC4-5D6E-409C-BE32-E72D297353CC}">
+                <c16:uniqueId val="{00000005-0F02-45FD-855C-7F1A26713155}"/>
+              </c:ext>
+            </c:extLst>
           </c:dPt>
+          <c:dLbls>
+            <c:numFmt formatCode="#,##0" sourceLinked="0"/>
+            <c:spPr>
+              <a:noFill/>
+              <a:ln>
+                <a:noFill/>
+              </a:ln>
+              <a:effectLst/>
+            </c:spPr>
+            <c:txPr>
+              <a:bodyPr/>
+              <a:lstStyle/>
+              <a:p>
+                <a:pPr>
+                  <a:defRPr sz="1100" b="0" i="0" u="none" strike="noStrike">
+                    <a:solidFill>
+                      <a:srgbClr val="1C2B2D"/>
+                    </a:solidFill>
+                    <a:latin typeface="+mn-lt"/>
+                  </a:defRPr>
+                </a:pPr>
+                <a:endParaRPr lang="es-CO"/>
+              </a:p>
+            </c:txPr>
+            <c:showLegendKey val="0"/>
+            <c:showVal val="1"/>
+            <c:showCatName val="0"/>
+            <c:showSerName val="0"/>
+            <c:showPercent val="0"/>
+            <c:showBubbleSize val="0"/>
+            <c:showLeaderLines val="0"/>
+            <c:extLst>
+              <c:ext xmlns:c15="http://schemas.microsoft.com/office/drawing/2012/chart" uri="{CE6537A1-D6FC-4f65-9D91-7224C49458BB}">
+                <c15:showLeaderLines val="0"/>
+              </c:ext>
+            </c:extLst>
+          </c:dLbls>
           <c:cat>
-            <c:multiLvlStrRef>
+            <c:strRef>
               <c:f>Sheet1!$A$2:$A$4</c:f>
-              <c:multiLvlStrCache>
+              <c:strCache>
                 <c:ptCount val="3"/>
-                <c:lvl>
-                  <c:pt idx="0">
-                    <c:v>AS-IS</c:v>
-                  </c:pt>
-                  <c:pt idx="1">
-                    <c:v>TO-BE sin medidas</c:v>
-                  </c:pt>
-                  <c:pt idx="2">
-                    <c:v>TO-BE con medidas</c:v>
-                  </c:pt>
-                </c:lvl>
-              </c:multiLvlStrCache>
-            </c:multiLvlStrRef>
+                <c:pt idx="0">
+                  <c:v>AS-IS</c:v>
+                </c:pt>
+                <c:pt idx="1">
+                  <c:v>TO-BE sin medidas</c:v>
+                </c:pt>
+                <c:pt idx="2">
+                  <c:v>TO-BE con medidas</c:v>
+                </c:pt>
+              </c:strCache>
+            </c:strRef>
           </c:cat>
           <c:val>
             <c:numRef>
@@ -609,36 +637,23 @@
               </c:numCache>
             </c:numRef>
           </c:val>
+          <c:extLst>
+            <c:ext xmlns:c16="http://schemas.microsoft.com/office/drawing/2014/chart" uri="{C3380CC4-5D6E-409C-BE32-E72D297353CC}">
+              <c16:uniqueId val="{00000006-0F02-45FD-855C-7F1A26713155}"/>
+            </c:ext>
+          </c:extLst>
         </c:ser>
         <c:dLbls>
-          <c:numFmt formatCode="#,##0" sourceLinked="0"/>
-          <c:txPr>
-            <a:bodyPr/>
-            <a:lstStyle/>
-            <a:p>
-              <a:pPr>
-                <a:defRPr b="0" i="0" strike="noStrike" sz="1100" u="none">
-                  <a:solidFill>
-                    <a:srgbClr val="1C2B2D"/>
-                  </a:solidFill>
-                  <a:latin typeface="+mn-lt"/>
-                </a:defRPr>
-              </a:pPr>
-            </a:p>
-          </c:txPr>
           <c:showLegendKey val="0"/>
           <c:showVal val="1"/>
           <c:showCatName val="0"/>
           <c:showSerName val="0"/>
           <c:showPercent val="0"/>
           <c:showBubbleSize val="0"/>
-          <c:showLeaderLines val="0"/>
         </c:dLbls>
         <c:gapWidth val="50"/>
-        <c:overlap val="0"/>
         <c:axId val="2094734554"/>
         <c:axId val="2094734552"/>
-        <c:axId val="2094734556"/>
       </c:barChart>
       <c:catAx>
         <c:axId val="2094734554"/>
@@ -679,6 +694,7 @@
         <c:crosses val="autoZero"/>
         <c:auto val="1"/>
         <c:lblAlgn val="ctr"/>
+        <c:lblOffset val="100"/>
         <c:noMultiLvlLbl val="1"/>
       </c:catAx>
       <c:valAx>
@@ -743,6 +759,7 @@
     </c:plotArea>
     <c:plotVisOnly val="1"/>
     <c:dispBlanksAs val="span"/>
+    <c:showDLblsOverMax val="1"/>
   </c:chart>
   <c:spPr>
     <a:noFill/>
@@ -758,9 +775,11 @@
 </file>
 
 <file path=ppt/charts/chart3.xml><?xml version="1.0" encoding="utf-8"?>
-<c:chartSpace xmlns:c="http://schemas.openxmlformats.org/drawingml/2006/chart" xmlns:a="http://schemas.openxmlformats.org/drawingml/2006/main" xmlns:r="http://schemas.openxmlformats.org/officeDocument/2006/relationships">
+<c:chartSpace xmlns:c="http://schemas.openxmlformats.org/drawingml/2006/chart" xmlns:a="http://schemas.openxmlformats.org/drawingml/2006/main" xmlns:r="http://schemas.openxmlformats.org/officeDocument/2006/relationships" xmlns:c16r2="http://schemas.microsoft.com/office/drawing/2015/06/chart">
   <c:date1904 val="0"/>
+  <c:lang val="es-ES"/>
   <c:roundedCorners val="1"/>
+  <c:style val="2"/>
   <c:chart>
     <c:title>
       <c:tx>
@@ -777,7 +796,7 @@
               </a:defRPr>
             </a:pPr>
             <a:r>
-              <a:rPr sz="1200" b="0" i="0" u="none" strike="noStrike">
+              <a:rPr lang="es-MX" sz="1200" b="0" i="0" u="none" strike="noStrike">
                 <a:solidFill>
                   <a:srgbClr val="0E3B43"/>
                 </a:solidFill>
@@ -788,7 +807,6 @@
           </a:p>
         </c:rich>
       </c:tx>
-      <c:layout/>
       <c:overlay val="0"/>
     </c:title>
     <c:autoTitleDeleted val="0"/>
@@ -819,30 +837,6 @@
             <a:effectLst/>
           </c:spPr>
           <c:invertIfNegative val="0"/>
-          <c:dLbls>
-            <c:numFmt formatCode="0.0&quot;%&quot;" sourceLinked="0"/>
-            <c:txPr>
-              <a:bodyPr/>
-              <a:lstStyle/>
-              <a:p>
-                <a:pPr>
-                  <a:defRPr b="0" i="0" strike="noStrike" sz="1100" u="none">
-                    <a:solidFill>
-                      <a:srgbClr val="1C2B2D"/>
-                    </a:solidFill>
-                    <a:latin typeface="+mn-lt"/>
-                  </a:defRPr>
-                </a:pPr>
-              </a:p>
-            </c:txPr>
-            <c:showLegendKey val="0"/>
-            <c:showVal val="1"/>
-            <c:showCatName val="0"/>
-            <c:showSerName val="0"/>
-            <c:showPercent val="0"/>
-            <c:showBubbleSize val="0"/>
-            <c:showLeaderLines val="0"/>
-          </c:dLbls>
           <c:dPt>
             <c:idx val="0"/>
             <c:invertIfNegative val="0"/>
@@ -853,6 +847,11 @@
               </a:solidFill>
               <a:effectLst/>
             </c:spPr>
+            <c:extLst>
+              <c:ext xmlns:c16="http://schemas.microsoft.com/office/drawing/2014/chart" uri="{C3380CC4-5D6E-409C-BE32-E72D297353CC}">
+                <c16:uniqueId val="{00000001-E6FF-40C0-9CDC-5FA8A7EDBBD1}"/>
+              </c:ext>
+            </c:extLst>
           </c:dPt>
           <c:dPt>
             <c:idx val="1"/>
@@ -864,6 +863,11 @@
               </a:solidFill>
               <a:effectLst/>
             </c:spPr>
+            <c:extLst>
+              <c:ext xmlns:c16="http://schemas.microsoft.com/office/drawing/2014/chart" uri="{C3380CC4-5D6E-409C-BE32-E72D297353CC}">
+                <c16:uniqueId val="{00000003-E6FF-40C0-9CDC-5FA8A7EDBBD1}"/>
+              </c:ext>
+            </c:extLst>
           </c:dPt>
           <c:dPt>
             <c:idx val="2"/>
@@ -875,6 +879,11 @@
               </a:solidFill>
               <a:effectLst/>
             </c:spPr>
+            <c:extLst>
+              <c:ext xmlns:c16="http://schemas.microsoft.com/office/drawing/2014/chart" uri="{C3380CC4-5D6E-409C-BE32-E72D297353CC}">
+                <c16:uniqueId val="{00000005-E6FF-40C0-9CDC-5FA8A7EDBBD1}"/>
+              </c:ext>
+            </c:extLst>
           </c:dPt>
           <c:dPt>
             <c:idx val="3"/>
@@ -886,28 +895,68 @@
               </a:solidFill>
               <a:effectLst/>
             </c:spPr>
+            <c:extLst>
+              <c:ext xmlns:c16="http://schemas.microsoft.com/office/drawing/2014/chart" uri="{C3380CC4-5D6E-409C-BE32-E72D297353CC}">
+                <c16:uniqueId val="{00000007-E6FF-40C0-9CDC-5FA8A7EDBBD1}"/>
+              </c:ext>
+            </c:extLst>
           </c:dPt>
+          <c:dLbls>
+            <c:numFmt formatCode="0.0&quot;%&quot;" sourceLinked="0"/>
+            <c:spPr>
+              <a:noFill/>
+              <a:ln>
+                <a:noFill/>
+              </a:ln>
+              <a:effectLst/>
+            </c:spPr>
+            <c:txPr>
+              <a:bodyPr/>
+              <a:lstStyle/>
+              <a:p>
+                <a:pPr>
+                  <a:defRPr sz="1100" b="0" i="0" u="none" strike="noStrike">
+                    <a:solidFill>
+                      <a:srgbClr val="1C2B2D"/>
+                    </a:solidFill>
+                    <a:latin typeface="+mn-lt"/>
+                  </a:defRPr>
+                </a:pPr>
+                <a:endParaRPr lang="es-CO"/>
+              </a:p>
+            </c:txPr>
+            <c:showLegendKey val="0"/>
+            <c:showVal val="1"/>
+            <c:showCatName val="0"/>
+            <c:showSerName val="0"/>
+            <c:showPercent val="0"/>
+            <c:showBubbleSize val="0"/>
+            <c:showLeaderLines val="0"/>
+            <c:extLst>
+              <c:ext xmlns:c15="http://schemas.microsoft.com/office/drawing/2012/chart" uri="{CE6537A1-D6FC-4f65-9D91-7224C49458BB}">
+                <c15:showLeaderLines val="0"/>
+              </c:ext>
+            </c:extLst>
+          </c:dLbls>
           <c:cat>
-            <c:multiLvlStrRef>
+            <c:strRef>
               <c:f>Sheet1!$A$2:$A$5</c:f>
-              <c:multiLvlStrCache>
+              <c:strCache>
                 <c:ptCount val="4"/>
-                <c:lvl>
-                  <c:pt idx="0">
-                    <c:v>Portal completo</c:v>
-                  </c:pt>
-                  <c:pt idx="1">
-                    <c:v>Opción 1</c:v>
-                  </c:pt>
-                  <c:pt idx="2">
-                    <c:v>Opción 2</c:v>
-                  </c:pt>
-                  <c:pt idx="3">
-                    <c:v>Opción 3 (adoptada)</c:v>
-                  </c:pt>
-                </c:lvl>
-              </c:multiLvlStrCache>
-            </c:multiLvlStrRef>
+                <c:pt idx="0">
+                  <c:v>Portal completo</c:v>
+                </c:pt>
+                <c:pt idx="1">
+                  <c:v>Opción 1</c:v>
+                </c:pt>
+                <c:pt idx="2">
+                  <c:v>Opción 2</c:v>
+                </c:pt>
+                <c:pt idx="3">
+                  <c:v>Opción 3 (adoptada)</c:v>
+                </c:pt>
+              </c:strCache>
+            </c:strRef>
           </c:cat>
           <c:val>
             <c:numRef>
@@ -930,36 +979,23 @@
               </c:numCache>
             </c:numRef>
           </c:val>
+          <c:extLst>
+            <c:ext xmlns:c16="http://schemas.microsoft.com/office/drawing/2014/chart" uri="{C3380CC4-5D6E-409C-BE32-E72D297353CC}">
+              <c16:uniqueId val="{00000008-E6FF-40C0-9CDC-5FA8A7EDBBD1}"/>
+            </c:ext>
+          </c:extLst>
         </c:ser>
         <c:dLbls>
-          <c:numFmt formatCode="0.0&quot;%&quot;" sourceLinked="0"/>
-          <c:txPr>
-            <a:bodyPr/>
-            <a:lstStyle/>
-            <a:p>
-              <a:pPr>
-                <a:defRPr b="0" i="0" strike="noStrike" sz="1100" u="none">
-                  <a:solidFill>
-                    <a:srgbClr val="1C2B2D"/>
-                  </a:solidFill>
-                  <a:latin typeface="+mn-lt"/>
-                </a:defRPr>
-              </a:pPr>
-            </a:p>
-          </c:txPr>
           <c:showLegendKey val="0"/>
           <c:showVal val="1"/>
           <c:showCatName val="0"/>
           <c:showSerName val="0"/>
           <c:showPercent val="0"/>
           <c:showBubbleSize val="0"/>
-          <c:showLeaderLines val="0"/>
         </c:dLbls>
         <c:gapWidth val="50"/>
-        <c:overlap val="0"/>
         <c:axId val="2094734554"/>
         <c:axId val="2094734552"/>
-        <c:axId val="2094734556"/>
       </c:barChart>
       <c:catAx>
         <c:axId val="2094734554"/>
@@ -1000,6 +1036,7 @@
         <c:crosses val="autoZero"/>
         <c:auto val="1"/>
         <c:lblAlgn val="ctr"/>
+        <c:lblOffset val="100"/>
         <c:noMultiLvlLbl val="1"/>
       </c:catAx>
       <c:valAx>
@@ -1064,6 +1101,7 @@
     </c:plotArea>
     <c:plotVisOnly val="1"/>
     <c:dispBlanksAs val="span"/>
+    <c:showDLblsOverMax val="1"/>
   </c:chart>
   <c:spPr>
     <a:noFill/>
@@ -1100,234 +1138,10 @@
           <a:chExt cx="0" cy="0"/>
         </a:xfrm>
       </p:grpSpPr>
-      <p:sp>
-        <p:nvSpPr>
-          <p:cNvPr id="2" name="Header Placeholder 1"/>
-          <p:cNvSpPr>
-            <a:spLocks noGrp="1"/>
-          </p:cNvSpPr>
-          <p:nvPr>
-            <p:ph type="hdr" sz="quarter"/>
-          </p:nvPr>
-        </p:nvSpPr>
-        <p:spPr>
-          <a:xfrm>
-            <a:off x="0" y="0"/>
-            <a:ext cx="2971800" cy="458788"/>
-          </a:xfrm>
-          <a:prstGeom prst="rect">
-            <a:avLst/>
-          </a:prstGeom>
-        </p:spPr>
-        <p:txBody>
-          <a:bodyPr vert="horz" lIns="91440" tIns="45720" rIns="91440" bIns="45720" rtlCol="0"/>
-          <a:lstStyle>
-            <a:lvl1pPr algn="l">
-              <a:defRPr sz="1200"/>
-            </a:lvl1pPr>
-          </a:lstStyle>
-          <a:p>
-            <a:endParaRPr lang="en-US"/>
-          </a:p>
-        </p:txBody>
-      </p:sp>
-      <p:sp>
-        <p:nvSpPr>
-          <p:cNvPr id="3" name="Date Placeholder 2"/>
-          <p:cNvSpPr>
-            <a:spLocks noGrp="1"/>
-          </p:cNvSpPr>
-          <p:nvPr>
-            <p:ph type="dt" idx="1"/>
-          </p:nvPr>
-        </p:nvSpPr>
-        <p:spPr>
-          <a:xfrm>
-            <a:off x="3884613" y="0"/>
-            <a:ext cx="2971800" cy="458788"/>
-          </a:xfrm>
-          <a:prstGeom prst="rect">
-            <a:avLst/>
-          </a:prstGeom>
-        </p:spPr>
-        <p:txBody>
-          <a:bodyPr vert="horz" lIns="91440" tIns="45720" rIns="91440" bIns="45720" rtlCol="0"/>
-          <a:lstStyle>
-            <a:lvl1pPr algn="r">
-              <a:defRPr sz="1200"/>
-            </a:lvl1pPr>
-          </a:lstStyle>
-          <a:p>
-            <a:fld id="{5282F153-3F37-0F45-9E97-73ACFA13230C}" type="datetimeFigureOut">
-              <a:rPr lang="en-US"/>
-              <a:t>7/23/19</a:t>
-            </a:fld>
-            <a:endParaRPr lang="en-US"/>
-          </a:p>
-        </p:txBody>
-      </p:sp>
-      <p:sp>
-        <p:nvSpPr>
-          <p:cNvPr id="4" name="Slide Image Placeholder 3"/>
-          <p:cNvSpPr>
-            <a:spLocks noGrp="1" noRot="1" noChangeAspect="1"/>
-          </p:cNvSpPr>
-          <p:nvPr>
-            <p:ph type="sldImg" idx="2"/>
-          </p:nvPr>
-        </p:nvSpPr>
-        <p:spPr>
-          <a:xfrm>
-            <a:off x="685800" y="1143000"/>
-            <a:ext cx="5486400" cy="3086100"/>
-          </a:xfrm>
-          <a:prstGeom prst="rect">
-            <a:avLst/>
-          </a:prstGeom>
-          <a:noFill/>
-          <a:ln w="12700">
-            <a:solidFill>
-              <a:prstClr val="black"/>
-            </a:solidFill>
-          </a:ln>
-        </p:spPr>
-        <p:txBody>
-          <a:bodyPr vert="horz" lIns="91440" tIns="45720" rIns="91440" bIns="45720" rtlCol="0" anchor="ctr"/>
-          <a:lstStyle/>
-          <a:p>
-            <a:endParaRPr lang="en-US"/>
-          </a:p>
-        </p:txBody>
-      </p:sp>
-      <p:sp>
-        <p:nvSpPr>
-          <p:cNvPr id="5" name="Notes Placeholder 4"/>
-          <p:cNvSpPr>
-            <a:spLocks noGrp="1"/>
-          </p:cNvSpPr>
-          <p:nvPr>
-            <p:ph type="body" sz="quarter" idx="3"/>
-          </p:nvPr>
-        </p:nvSpPr>
-        <p:spPr>
-          <a:xfrm>
-            <a:off x="685800" y="4400550"/>
-            <a:ext cx="5486400" cy="3600450"/>
-          </a:xfrm>
-          <a:prstGeom prst="rect">
-            <a:avLst/>
-          </a:prstGeom>
-        </p:spPr>
-        <p:txBody>
-          <a:bodyPr vert="horz" lIns="91440" tIns="45720" rIns="91440" bIns="45720" rtlCol="0"/>
-          <a:lstStyle/>
-          <a:p>
-            <a:pPr lvl="0"/>
-            <a:r>
-              <a:rPr lang="en-US"/>
-              <a:t>Click to edit Master text styles</a:t>
-            </a:r>
-          </a:p>
-          <a:p>
-            <a:pPr lvl="1"/>
-            <a:r>
-              <a:rPr lang="en-US"/>
-              <a:t>Second level</a:t>
-            </a:r>
-          </a:p>
-          <a:p>
-            <a:pPr lvl="2"/>
-            <a:r>
-              <a:rPr lang="en-US"/>
-              <a:t>Third level</a:t>
-            </a:r>
-          </a:p>
-          <a:p>
-            <a:pPr lvl="3"/>
-            <a:r>
-              <a:rPr lang="en-US"/>
-              <a:t>Fourth level</a:t>
-            </a:r>
-          </a:p>
-          <a:p>
-            <a:pPr lvl="4"/>
-            <a:r>
-              <a:rPr lang="en-US"/>
-              <a:t>Fifth level</a:t>
-            </a:r>
-          </a:p>
-        </p:txBody>
-      </p:sp>
-      <p:sp>
-        <p:nvSpPr>
-          <p:cNvPr id="6" name="Footer Placeholder 5"/>
-          <p:cNvSpPr>
-            <a:spLocks noGrp="1"/>
-          </p:cNvSpPr>
-          <p:nvPr>
-            <p:ph type="ftr" sz="quarter" idx="4"/>
-          </p:nvPr>
-        </p:nvSpPr>
-        <p:spPr>
-          <a:xfrm>
-            <a:off x="0" y="8685213"/>
-            <a:ext cx="2971800" cy="458787"/>
-          </a:xfrm>
-          <a:prstGeom prst="rect">
-            <a:avLst/>
-          </a:prstGeom>
-        </p:spPr>
-        <p:txBody>
-          <a:bodyPr vert="horz" lIns="91440" tIns="45720" rIns="91440" bIns="45720" rtlCol="0" anchor="b"/>
-          <a:lstStyle>
-            <a:lvl1pPr algn="l">
-              <a:defRPr sz="1200"/>
-            </a:lvl1pPr>
-          </a:lstStyle>
-          <a:p>
-            <a:endParaRPr lang="en-US"/>
-          </a:p>
-        </p:txBody>
-      </p:sp>
-      <p:sp>
-        <p:nvSpPr>
-          <p:cNvPr id="7" name="Slide Number Placeholder 6"/>
-          <p:cNvSpPr>
-            <a:spLocks noGrp="1"/>
-          </p:cNvSpPr>
-          <p:nvPr>
-            <p:ph type="sldNum" sz="quarter" idx="5"/>
-          </p:nvPr>
-        </p:nvSpPr>
-        <p:spPr>
-          <a:xfrm>
-            <a:off x="3884613" y="8685213"/>
-            <a:ext cx="2971800" cy="458787"/>
-          </a:xfrm>
-          <a:prstGeom prst="rect">
-            <a:avLst/>
-          </a:prstGeom>
-        </p:spPr>
-        <p:txBody>
-          <a:bodyPr vert="horz" lIns="91440" tIns="45720" rIns="91440" bIns="45720" rtlCol="0" anchor="b"/>
-          <a:lstStyle>
-            <a:lvl1pPr algn="r">
-              <a:defRPr sz="1200"/>
-            </a:lvl1pPr>
-          </a:lstStyle>
-          <a:p>
-            <a:fld id="{CE5E9CC1-C706-0F49-92D6-E571CC5EEA8F}" type="slidenum">
-              <a:rPr lang="en-US"/>
-              <a:t>‹#›</a:t>
-            </a:fld>
-            <a:endParaRPr lang="en-US"/>
-          </a:p>
-        </p:txBody>
-      </p:sp>
     </p:spTree>
     <p:extLst>
       <p:ext uri="{BB962C8B-B14F-4D97-AF65-F5344CB8AC3E}">
-        <p14:creationId xmlns:p14="http://schemas.microsoft.com/office/powerpoint/2010/main" val="1024086991"/>
+        <p14:creationId xmlns:p14="http://schemas.microsoft.com/office/powerpoint/2010/main" val="2742676488"/>
       </p:ext>
     </p:extLst>
   </p:cSld>
@@ -1475,7 +1289,6 @@
               <a:rPr lang="en-US" dirty="0"/>
               <a:t>Presentación ejecutiva del proyecto de automatización del tramo de expediente del crédito preaprobado de la feria Expomóvil.</a:t>
             </a:r>
-            <a:endParaRPr lang="en-US" dirty="0"/>
           </a:p>
         </p:txBody>
       </p:sp>
@@ -1563,7 +1376,6 @@
               <a:rPr lang="en-US" dirty="0"/>
               <a:t>Otros riesgos: datos personales en la web, errores de la validación automática, adopción del portal y que la comisión del mensajero desanime a algunos clientes (respaldo: entrega en sucursal).</a:t>
             </a:r>
-            <a:endParaRPr lang="en-US" dirty="0"/>
           </a:p>
         </p:txBody>
       </p:sp>
@@ -1651,7 +1463,6 @@
               <a:rPr lang="en-US" dirty="0"/>
               <a:t>Todo el trabajo está versionado en el repositorio Flujo-de-credito (GitHub). Los BPMN nunca se sobrescriben: cada cambio crea una versión nueva.</a:t>
             </a:r>
-            <a:endParaRPr lang="en-US" dirty="0"/>
           </a:p>
         </p:txBody>
       </p:sp>
@@ -1739,7 +1550,6 @@
               <a:rPr lang="en-US" dirty="0"/>
               <a:t>El MVP es una demostración: no cambia el ROI ni los KPI del tablero. Corre en modo simulado; la conexión con Camunda real no forma parte del terminado.</a:t>
             </a:r>
-            <a:endParaRPr lang="en-US" dirty="0"/>
           </a:p>
         </p:txBody>
       </p:sp>
@@ -1827,7 +1637,6 @@
               <a:rPr lang="en-US" dirty="0"/>
               <a:t>Con datos reales del piloto se reemplazan las hipótesis de horas y conversión de tiempo, y se recalcula el ROI.</a:t>
             </a:r>
-            <a:endParaRPr lang="en-US" dirty="0"/>
           </a:p>
         </p:txBody>
       </p:sp>
@@ -1915,7 +1724,6 @@
               <a:rPr lang="en-US" dirty="0"/>
               <a:t>Mensaje principal: el paquete A (portal + validación + recogida + consulta de estado) cumple la meta de 6 días. El ROI positivo depende de convertir el tiempo liberado en caja (Opción 2).</a:t>
             </a:r>
-            <a:endParaRPr lang="en-US" dirty="0"/>
           </a:p>
         </p:txBody>
       </p:sp>
@@ -2003,7 +1811,6 @@
               <a:rPr lang="en-US" dirty="0"/>
               <a:t>Fuente: Excel de tiempos (estimado) y entrevista. Volumen de ejemplo: 1.000 solicitudes por mes de feria, 400 llegan a expediente.</a:t>
             </a:r>
-            <a:endParaRPr lang="en-US" dirty="0"/>
           </a:p>
         </p:txBody>
       </p:sp>
@@ -2091,7 +1898,6 @@
               <a:rPr lang="en-US" dirty="0"/>
               <a:t>Cinco porqués de P-01 confirmados por el entrevistado (PRIO-2). P-02 y P-03 tienen niveles pendientes.</a:t>
             </a:r>
-            <a:endParaRPr lang="en-US" dirty="0"/>
           </a:p>
         </p:txBody>
       </p:sp>
@@ -2179,7 +1985,6 @@
               <a:rPr lang="en-US" dirty="0"/>
               <a:t>Matriz didáctica: cliente 25 %, volumen 20 %, urgencia 15 %, factibilidad 20 %, riesgo 20 %. Puntajes son hipótesis para discutir.</a:t>
             </a:r>
-            <a:endParaRPr lang="en-US" dirty="0"/>
           </a:p>
         </p:txBody>
       </p:sp>
@@ -2267,7 +2072,6 @@
               <a:rPr lang="en-US" dirty="0"/>
               <a:t>BPMN TO-BE v03 para Camunda 8.10. Riesgo: si el escaneo sigue tardando 3 días, la meta queda sin margen.</a:t>
             </a:r>
-            <a:endParaRPr lang="en-US" dirty="0"/>
           </a:p>
         </p:txBody>
       </p:sp>
@@ -2355,7 +2159,6 @@
               <a:rPr lang="en-US" dirty="0"/>
               <a:t>Hipótesis H-2b: la mitad de los cierres en el portal se evitan. Costo de llamadas y asistencia estimado en menos de RD$ 20.000 al año.</a:t>
             </a:r>
-            <a:endParaRPr lang="en-US" dirty="0"/>
           </a:p>
         </p:txBody>
       </p:sp>
@@ -2443,7 +2246,6 @@
               <a:rPr lang="en-US" dirty="0"/>
               <a:t>Los valores sintéticos vienen del reporte de validación de Preset (14,93 vs 7,81 días; 20 % vs 6,9 %; 10,5 % vs 2,8 %).</a:t>
             </a:r>
-            <a:endParaRPr lang="en-US" dirty="0"/>
           </a:p>
         </p:txBody>
       </p:sp>
@@ -2531,7 +2333,6 @@
               <a:rPr lang="en-US" dirty="0"/>
               <a:t>Opción 3 = versión mínima sobre Camunda 8.10 + mensajero de tercero cobrado al cliente + tiempo liberado convertido en caja (≈ 2,7 puestos fuera de feria). Cifras en pesos dominicanos.</a:t>
             </a:r>
-            <a:endParaRPr lang="en-US" dirty="0"/>
           </a:p>
         </p:txBody>
       </p:sp>
@@ -2609,6 +2410,7 @@
         <a:solidFill>
           <a:schemeClr val="tx2"/>
         </a:solidFill>
+        <a:effectLst/>
       </p:bgPr>
     </p:bg>
     <p:spTree>
@@ -2628,9 +2430,11 @@
       <p:sp>
         <p:nvSpPr>
           <p:cNvPr id="2" name="Text 0"/>
-          <p:cNvSpPr/>
+          <p:cNvSpPr>
+            <a:spLocks noGrp="1"/>
+          </p:cNvSpPr>
           <p:nvPr>
-            <p:ph idx="100" type="title" hasCustomPrompt="1"/>
+            <p:ph type="title" idx="100" hasCustomPrompt="1"/>
           </p:nvPr>
         </p:nvSpPr>
         <p:spPr>
@@ -2647,7 +2451,7 @@
         <p:txBody>
           <a:bodyPr wrap="square" rtlCol="0"/>
           <a:lstStyle>
-            <a:lvl1pPr indent="0" marL="0">
+            <a:lvl1pPr marL="0" indent="0">
               <a:buNone/>
               <a:defRPr lang="en-US" sz="3800" b="1" dirty="0">
                 <a:solidFill>
@@ -2660,7 +2464,7 @@
             </a:lvl1pPr>
           </a:lstStyle>
           <a:p>
-            <a:pPr indent="0" marL="0">
+            <a:pPr marL="0" indent="0">
               <a:buNone/>
             </a:pPr>
             <a:endParaRPr lang="en-US" sz="3800" dirty="0"/>
@@ -2670,9 +2474,11 @@
       <p:sp>
         <p:nvSpPr>
           <p:cNvPr id="3" name="Text 0"/>
-          <p:cNvSpPr/>
+          <p:cNvSpPr>
+            <a:spLocks noGrp="1"/>
+          </p:cNvSpPr>
           <p:nvPr>
-            <p:ph idx="101" type="body" hasCustomPrompt="1"/>
+            <p:ph type="body" idx="101" hasCustomPrompt="1"/>
           </p:nvPr>
         </p:nvSpPr>
         <p:spPr>
@@ -2689,7 +2495,7 @@
         <p:txBody>
           <a:bodyPr wrap="square" rtlCol="0"/>
           <a:lstStyle>
-            <a:lvl1pPr indent="0" marL="0">
+            <a:lvl1pPr marL="0" indent="0">
               <a:buNone/>
               <a:defRPr lang="en-US" sz="1600" dirty="0">
                 <a:solidFill>
@@ -2699,7 +2505,7 @@
             </a:lvl1pPr>
           </a:lstStyle>
           <a:p>
-            <a:pPr indent="0" marL="0">
+            <a:pPr marL="0" indent="0">
               <a:buNone/>
             </a:pPr>
             <a:endParaRPr lang="en-US" sz="1600" dirty="0"/>
@@ -2722,6 +2528,7 @@
         <a:solidFill>
           <a:schemeClr val="tx2"/>
         </a:solidFill>
+        <a:effectLst/>
       </p:bgPr>
     </p:bg>
     <p:spTree>
@@ -2741,9 +2548,11 @@
       <p:sp>
         <p:nvSpPr>
           <p:cNvPr id="2" name="Text 0"/>
-          <p:cNvSpPr/>
+          <p:cNvSpPr>
+            <a:spLocks noGrp="1"/>
+          </p:cNvSpPr>
           <p:nvPr>
-            <p:ph idx="100" type="title" hasCustomPrompt="1"/>
+            <p:ph type="title" idx="100" hasCustomPrompt="1"/>
           </p:nvPr>
         </p:nvSpPr>
         <p:spPr>
@@ -2760,7 +2569,7 @@
         <p:txBody>
           <a:bodyPr wrap="square" rtlCol="0"/>
           <a:lstStyle>
-            <a:lvl1pPr indent="0" marL="0">
+            <a:lvl1pPr marL="0" indent="0">
               <a:buNone/>
               <a:defRPr lang="en-US" sz="3800" b="1" dirty="0">
                 <a:solidFill>
@@ -2773,7 +2582,7 @@
             </a:lvl1pPr>
           </a:lstStyle>
           <a:p>
-            <a:pPr indent="0" marL="0">
+            <a:pPr marL="0" indent="0">
               <a:buNone/>
             </a:pPr>
             <a:endParaRPr lang="en-US" sz="3800" dirty="0"/>
@@ -2796,6 +2605,7 @@
         <a:solidFill>
           <a:schemeClr val="bg1"/>
         </a:solidFill>
+        <a:effectLst/>
       </p:bgPr>
     </p:bg>
     <p:spTree>
@@ -2815,9 +2625,11 @@
       <p:sp>
         <p:nvSpPr>
           <p:cNvPr id="2" name="Text 0"/>
-          <p:cNvSpPr/>
+          <p:cNvSpPr>
+            <a:spLocks noGrp="1"/>
+          </p:cNvSpPr>
           <p:nvPr>
-            <p:ph idx="100" type="title" hasCustomPrompt="1"/>
+            <p:ph type="title" idx="100" hasCustomPrompt="1"/>
           </p:nvPr>
         </p:nvSpPr>
         <p:spPr>
@@ -2834,7 +2646,7 @@
         <p:txBody>
           <a:bodyPr wrap="square" rtlCol="0"/>
           <a:lstStyle>
-            <a:lvl1pPr indent="0" marL="0">
+            <a:lvl1pPr marL="0" indent="0">
               <a:buNone/>
               <a:defRPr lang="en-US" sz="2600" b="1" dirty="0">
                 <a:solidFill>
@@ -2847,7 +2659,7 @@
             </a:lvl1pPr>
           </a:lstStyle>
           <a:p>
-            <a:pPr indent="0" marL="0">
+            <a:pPr marL="0" indent="0">
               <a:buNone/>
             </a:pPr>
             <a:endParaRPr lang="en-US" sz="2600" dirty="0"/>
@@ -2875,7 +2687,7 @@
           <a:bodyPr wrap="square" lIns="0" tIns="0" rIns="0" bIns="0" rtlCol="0" anchor="ctr"/>
           <a:lstStyle/>
           <a:p>
-            <a:pPr indent="0" marL="0">
+            <a:pPr marL="0" indent="0">
               <a:buNone/>
             </a:pPr>
             <a:r>
@@ -2910,7 +2722,7 @@
           </a:prstGeom>
           <a:extLst>
             <a:ext uri="{C572A759-6A51-4108-AA02-DFA0A04FC94B}">
-              <ma14:wrappingTextBoxFlag xmlns:ma14="http://schemas.microsoft.com/office/mac/drawingml/2011/main" val="0"/>
+              <ma14:wrappingTextBoxFlag xmlns:ma14="http://schemas.microsoft.com/office/mac/drawingml/2011/main" xmlns="" val="0"/>
             </a:ext>
           </a:extLst>
         </p:spPr>
@@ -2928,8 +2740,8 @@
           <a:p>
             <a:pPr algn="r"/>
             <a:fld id="{F7021451-1387-4CA6-816F-3879F97B5CBC}" type="slidenum">
-              <a:rPr b="0" lang="en-US"/>
-              <a:t>1004</a:t>
+              <a:rPr lang="en-US" b="0"/>
+              <a:t>‹Nº›</a:t>
             </a:fld>
             <a:endParaRPr lang="en-US"/>
           </a:p>
@@ -2946,6 +2758,11 @@
 <file path=ppt/slideMasters/slideMaster1.xml><?xml version="1.0" encoding="utf-8"?>
 <p:sldMaster xmlns:a="http://schemas.openxmlformats.org/drawingml/2006/main" xmlns:r="http://schemas.openxmlformats.org/officeDocument/2006/relationships" xmlns:p="http://schemas.openxmlformats.org/presentationml/2006/main">
   <p:cSld>
+    <p:bg>
+      <p:bgRef idx="1001">
+        <a:schemeClr val="bg1"/>
+      </p:bgRef>
+    </p:bg>
     <p:spTree>
       <p:nvGrpSpPr>
         <p:cNvPr id="1" name=""/>
@@ -2980,7 +2797,7 @@
           </a:prstGeom>
           <a:extLst>
             <a:ext uri="{C572A759-6A51-4108-AA02-DFA0A04FC94B}">
-              <ma14:wrappingTextBoxFlag xmlns:ma14="http://schemas.microsoft.com/office/mac/drawingml/2011/main" val="0"/>
+              <ma14:wrappingTextBoxFlag xmlns:ma14="http://schemas.microsoft.com/office/mac/drawingml/2011/main" xmlns="" val="0"/>
             </a:ext>
           </a:extLst>
         </p:spPr>
@@ -2998,8 +2815,8 @@
           <a:p>
             <a:pPr algn="r"/>
             <a:fld id="{F7021451-1387-4CA6-816F-3879F97B5CBC}" type="slidenum">
-              <a:rPr b="0" lang="en-US"/>
-              <a:t>null</a:t>
+              <a:rPr lang="en-US" b="0"/>
+              <a:t>‹Nº›</a:t>
             </a:fld>
             <a:endParaRPr lang="en-US"/>
           </a:p>
@@ -3288,9 +3105,11 @@
       <p:sp>
         <p:nvSpPr>
           <p:cNvPr id="2" name="Text 0"/>
-          <p:cNvSpPr/>
+          <p:cNvSpPr>
+            <a:spLocks noGrp="1"/>
+          </p:cNvSpPr>
           <p:nvPr>
-            <p:ph idx="100" type="title" hasCustomPrompt="1"/>
+            <p:ph type="title" idx="100" hasCustomPrompt="1"/>
           </p:nvPr>
         </p:nvSpPr>
         <p:spPr>
@@ -3308,7 +3127,7 @@
           <a:bodyPr wrap="square" lIns="0" tIns="0" rIns="0" bIns="0" rtlCol="0" anchor="b"/>
           <a:lstStyle/>
           <a:p>
-            <a:pPr indent="0" marL="0">
+            <a:pPr marL="0" indent="0">
               <a:buNone/>
             </a:pPr>
             <a:r>
@@ -3329,9 +3148,11 @@
       <p:sp>
         <p:nvSpPr>
           <p:cNvPr id="3" name="Text 0"/>
-          <p:cNvSpPr/>
+          <p:cNvSpPr>
+            <a:spLocks noGrp="1"/>
+          </p:cNvSpPr>
           <p:nvPr>
-            <p:ph idx="101" type="body" hasCustomPrompt="1"/>
+            <p:ph type="body" idx="101" hasCustomPrompt="1"/>
           </p:nvPr>
         </p:nvSpPr>
         <p:spPr>
@@ -3349,7 +3170,7 @@
           <a:bodyPr wrap="square" lIns="0" tIns="0" rIns="0" bIns="0" rtlCol="0" anchor="t"/>
           <a:lstStyle/>
           <a:p>
-            <a:pPr indent="0" marL="0">
+            <a:pPr marL="0" indent="0">
               <a:buNone/>
             </a:pPr>
             <a:r>
@@ -3363,16 +3184,24 @@
             <a:endParaRPr lang="en-US" sz="1600" dirty="0"/>
           </a:p>
           <a:p>
-            <a:pPr indent="0" marL="0">
-              <a:buNone/>
-            </a:pPr>
+            <a:pPr marL="0" indent="0">
+              <a:buNone/>
+            </a:pPr>
+            <a:r>
+              <a:rPr lang="en-US" sz="1600" dirty="0" err="1">
+                <a:solidFill>
+                  <a:schemeClr val="accent5"/>
+                </a:solidFill>
+              </a:rPr>
+              <a:t>Octubre</a:t>
+            </a:r>
             <a:r>
               <a:rPr lang="en-US" sz="1600" dirty="0">
                 <a:solidFill>
                   <a:schemeClr val="accent5"/>
                 </a:solidFill>
               </a:rPr>
-              <a:t>Resumen ejecutivo del proceso, de AS-IS a MVP · octubre 2026</a:t>
+              <a:t> 2026</a:t>
             </a:r>
             <a:endParaRPr lang="en-US" sz="1600" dirty="0"/>
           </a:p>
@@ -3402,6 +3231,13 @@
             <a:prstDash val="solid"/>
           </a:ln>
         </p:spPr>
+        <p:txBody>
+          <a:bodyPr/>
+          <a:lstStyle/>
+          <a:p>
+            <a:endParaRPr lang="es-CO"/>
+          </a:p>
+        </p:txBody>
       </p:sp>
       <p:sp>
         <p:nvSpPr>
@@ -3424,7 +3260,7 @@
           <a:bodyPr wrap="square" lIns="0" tIns="0" rIns="0" bIns="0" rtlCol="0" anchor="t"/>
           <a:lstStyle/>
           <a:p>
-            <a:pPr indent="0" marL="0">
+            <a:pPr marL="0" indent="0">
               <a:buNone/>
             </a:pPr>
             <a:r>
@@ -3433,7 +3269,7 @@
                   <a:schemeClr val="bg1"/>
                 </a:solidFill>
               </a:rPr>
-              <a:t>Ana Ochoa · equipo: David, Sergio, Juan David</a:t>
+              <a:t>David Medellin, Sergio Gutierrez, Juan David Cardenas y Ana Ochoa</a:t>
             </a:r>
             <a:endParaRPr lang="en-US" sz="1200" dirty="0"/>
           </a:p>
@@ -3467,9 +3303,11 @@
       <p:sp>
         <p:nvSpPr>
           <p:cNvPr id="2" name="Text 0"/>
-          <p:cNvSpPr/>
+          <p:cNvSpPr>
+            <a:spLocks noGrp="1"/>
+          </p:cNvSpPr>
           <p:nvPr>
-            <p:ph idx="100" type="title" hasCustomPrompt="1"/>
+            <p:ph type="title" idx="100" hasCustomPrompt="1"/>
           </p:nvPr>
         </p:nvSpPr>
         <p:spPr>
@@ -3487,7 +3325,7 @@
           <a:bodyPr wrap="square" lIns="0" tIns="0" rIns="0" bIns="0" rtlCol="0" anchor="ctr"/>
           <a:lstStyle/>
           <a:p>
-            <a:pPr indent="0" marL="0">
+            <a:pPr marL="0" indent="0">
               <a:buNone/>
             </a:pPr>
             <a:r>
@@ -3531,6 +3369,13 @@
             <a:prstDash val="solid"/>
           </a:ln>
         </p:spPr>
+        <p:txBody>
+          <a:bodyPr/>
+          <a:lstStyle/>
+          <a:p>
+            <a:endParaRPr lang="es-CO"/>
+          </a:p>
+        </p:txBody>
       </p:sp>
       <p:sp>
         <p:nvSpPr>
@@ -3556,6 +3401,13 @@
             <a:prstDash val="solid"/>
           </a:ln>
         </p:spPr>
+        <p:txBody>
+          <a:bodyPr/>
+          <a:lstStyle/>
+          <a:p>
+            <a:endParaRPr lang="es-CO"/>
+          </a:p>
+        </p:txBody>
       </p:sp>
       <p:sp>
         <p:nvSpPr>
@@ -3578,7 +3430,7 @@
           <a:bodyPr wrap="square" lIns="0" tIns="0" rIns="0" bIns="0" rtlCol="0" anchor="ctr"/>
           <a:lstStyle/>
           <a:p>
-            <a:pPr algn="ctr" indent="0" marL="0">
+            <a:pPr marL="0" indent="0" algn="ctr">
               <a:buNone/>
             </a:pPr>
             <a:r>
@@ -3614,7 +3466,7 @@
           <a:bodyPr wrap="square" lIns="0" tIns="0" rIns="0" bIns="0" rtlCol="0" anchor="t"/>
           <a:lstStyle/>
           <a:p>
-            <a:pPr indent="0" marL="0">
+            <a:pPr marL="0" indent="0">
               <a:buNone/>
             </a:pPr>
             <a:r>
@@ -3650,7 +3502,7 @@
           <a:bodyPr wrap="square" lIns="0" tIns="0" rIns="0" bIns="0" rtlCol="0" anchor="t"/>
           <a:lstStyle/>
           <a:p>
-            <a:pPr indent="0" marL="0">
+            <a:pPr marL="0" indent="0">
               <a:buNone/>
             </a:pPr>
             <a:r>
@@ -3691,6 +3543,13 @@
             <a:prstDash val="solid"/>
           </a:ln>
         </p:spPr>
+        <p:txBody>
+          <a:bodyPr/>
+          <a:lstStyle/>
+          <a:p>
+            <a:endParaRPr lang="es-CO"/>
+          </a:p>
+        </p:txBody>
       </p:sp>
       <p:sp>
         <p:nvSpPr>
@@ -3716,6 +3575,13 @@
             <a:prstDash val="solid"/>
           </a:ln>
         </p:spPr>
+        <p:txBody>
+          <a:bodyPr/>
+          <a:lstStyle/>
+          <a:p>
+            <a:endParaRPr lang="es-CO"/>
+          </a:p>
+        </p:txBody>
       </p:sp>
       <p:sp>
         <p:nvSpPr>
@@ -3738,7 +3604,7 @@
           <a:bodyPr wrap="square" lIns="0" tIns="0" rIns="0" bIns="0" rtlCol="0" anchor="ctr"/>
           <a:lstStyle/>
           <a:p>
-            <a:pPr algn="ctr" indent="0" marL="0">
+            <a:pPr marL="0" indent="0" algn="ctr">
               <a:buNone/>
             </a:pPr>
             <a:r>
@@ -3774,7 +3640,7 @@
           <a:bodyPr wrap="square" lIns="0" tIns="0" rIns="0" bIns="0" rtlCol="0" anchor="t"/>
           <a:lstStyle/>
           <a:p>
-            <a:pPr indent="0" marL="0">
+            <a:pPr marL="0" indent="0">
               <a:buNone/>
             </a:pPr>
             <a:r>
@@ -3810,7 +3676,7 @@
           <a:bodyPr wrap="square" lIns="0" tIns="0" rIns="0" bIns="0" rtlCol="0" anchor="t"/>
           <a:lstStyle/>
           <a:p>
-            <a:pPr indent="0" marL="0">
+            <a:pPr marL="0" indent="0">
               <a:buNone/>
             </a:pPr>
             <a:r>
@@ -3851,6 +3717,13 @@
             <a:prstDash val="solid"/>
           </a:ln>
         </p:spPr>
+        <p:txBody>
+          <a:bodyPr/>
+          <a:lstStyle/>
+          <a:p>
+            <a:endParaRPr lang="es-CO"/>
+          </a:p>
+        </p:txBody>
       </p:sp>
       <p:sp>
         <p:nvSpPr>
@@ -3876,6 +3749,13 @@
             <a:prstDash val="solid"/>
           </a:ln>
         </p:spPr>
+        <p:txBody>
+          <a:bodyPr/>
+          <a:lstStyle/>
+          <a:p>
+            <a:endParaRPr lang="es-CO"/>
+          </a:p>
+        </p:txBody>
       </p:sp>
       <p:sp>
         <p:nvSpPr>
@@ -3898,7 +3778,7 @@
           <a:bodyPr wrap="square" lIns="0" tIns="0" rIns="0" bIns="0" rtlCol="0" anchor="ctr"/>
           <a:lstStyle/>
           <a:p>
-            <a:pPr algn="ctr" indent="0" marL="0">
+            <a:pPr marL="0" indent="0" algn="ctr">
               <a:buNone/>
             </a:pPr>
             <a:r>
@@ -3934,7 +3814,7 @@
           <a:bodyPr wrap="square" lIns="0" tIns="0" rIns="0" bIns="0" rtlCol="0" anchor="t"/>
           <a:lstStyle/>
           <a:p>
-            <a:pPr indent="0" marL="0">
+            <a:pPr marL="0" indent="0">
               <a:buNone/>
             </a:pPr>
             <a:r>
@@ -3970,7 +3850,7 @@
           <a:bodyPr wrap="square" lIns="0" tIns="0" rIns="0" bIns="0" rtlCol="0" anchor="t"/>
           <a:lstStyle/>
           <a:p>
-            <a:pPr indent="0" marL="0">
+            <a:pPr marL="0" indent="0">
               <a:buNone/>
             </a:pPr>
             <a:r>
@@ -4005,7 +3885,7 @@
           </a:prstGeom>
           <a:extLst>
             <a:ext uri="{C572A759-6A51-4108-AA02-DFA0A04FC94B}">
-              <ma14:wrappingTextBoxFlag xmlns:ma14="http://schemas.microsoft.com/office/mac/drawingml/2011/main" val="0"/>
+              <ma14:wrappingTextBoxFlag xmlns:ma14="http://schemas.microsoft.com/office/mac/drawingml/2011/main" xmlns="" val="0"/>
             </a:ext>
           </a:extLst>
         </p:spPr>
@@ -4023,7 +3903,7 @@
           <a:p>
             <a:pPr algn="r"/>
             <a:fld id="{F7021451-1387-4CA6-816F-3879F97B5CBC}" type="slidenum">
-              <a:rPr b="0" lang="en-US"/>
+              <a:rPr lang="en-US" b="0"/>
               <a:t>10</a:t>
             </a:fld>
             <a:endParaRPr lang="en-US"/>
@@ -4058,9 +3938,11 @@
       <p:sp>
         <p:nvSpPr>
           <p:cNvPr id="2" name="Text 0"/>
-          <p:cNvSpPr/>
+          <p:cNvSpPr>
+            <a:spLocks noGrp="1"/>
+          </p:cNvSpPr>
           <p:nvPr>
-            <p:ph idx="100" type="title" hasCustomPrompt="1"/>
+            <p:ph type="title" idx="100" hasCustomPrompt="1"/>
           </p:nvPr>
         </p:nvSpPr>
         <p:spPr>
@@ -4078,7 +3960,7 @@
           <a:bodyPr wrap="square" lIns="0" tIns="0" rIns="0" bIns="0" rtlCol="0" anchor="ctr"/>
           <a:lstStyle/>
           <a:p>
-            <a:pPr indent="0" marL="0">
+            <a:pPr marL="0" indent="0">
               <a:buNone/>
             </a:pPr>
             <a:r>
@@ -4118,6 +4000,13 @@
             <a:prstDash val="solid"/>
           </a:ln>
         </p:spPr>
+        <p:txBody>
+          <a:bodyPr/>
+          <a:lstStyle/>
+          <a:p>
+            <a:endParaRPr lang="es-CO"/>
+          </a:p>
+        </p:txBody>
       </p:sp>
       <p:sp>
         <p:nvSpPr>
@@ -4143,6 +4032,13 @@
             <a:prstDash val="solid"/>
           </a:ln>
         </p:spPr>
+        <p:txBody>
+          <a:bodyPr/>
+          <a:lstStyle/>
+          <a:p>
+            <a:endParaRPr lang="es-CO"/>
+          </a:p>
+        </p:txBody>
       </p:sp>
       <p:sp>
         <p:nvSpPr>
@@ -4165,7 +4061,7 @@
           <a:bodyPr wrap="square" lIns="0" tIns="0" rIns="0" bIns="0" rtlCol="0" anchor="ctr"/>
           <a:lstStyle/>
           <a:p>
-            <a:pPr algn="ctr" indent="0" marL="0">
+            <a:pPr marL="0" indent="0" algn="ctr">
               <a:buNone/>
             </a:pPr>
             <a:r>
@@ -4201,7 +4097,7 @@
           <a:bodyPr wrap="square" lIns="0" tIns="0" rIns="0" bIns="0" rtlCol="0" anchor="t"/>
           <a:lstStyle/>
           <a:p>
-            <a:pPr algn="ctr" indent="0" marL="0">
+            <a:pPr marL="0" indent="0" algn="ctr">
               <a:buNone/>
             </a:pPr>
             <a:r>
@@ -4237,7 +4133,7 @@
           <a:bodyPr wrap="square" lIns="0" tIns="0" rIns="0" bIns="0" rtlCol="0" anchor="t"/>
           <a:lstStyle/>
           <a:p>
-            <a:pPr algn="ctr" indent="0" marL="0">
+            <a:pPr marL="0" indent="0" algn="ctr">
               <a:buNone/>
             </a:pPr>
             <a:r>
@@ -4273,7 +4169,7 @@
           <a:bodyPr wrap="square" lIns="0" tIns="0" rIns="0" bIns="0" rtlCol="0" anchor="t"/>
           <a:lstStyle/>
           <a:p>
-            <a:pPr algn="ctr" indent="0" marL="0">
+            <a:pPr marL="0" indent="0" algn="ctr">
               <a:buNone/>
             </a:pPr>
             <a:r>
@@ -4312,6 +4208,13 @@
             <a:prstDash val="solid"/>
           </a:ln>
         </p:spPr>
+        <p:txBody>
+          <a:bodyPr/>
+          <a:lstStyle/>
+          <a:p>
+            <a:endParaRPr lang="es-CO"/>
+          </a:p>
+        </p:txBody>
       </p:sp>
       <p:sp>
         <p:nvSpPr>
@@ -4334,7 +4237,7 @@
           <a:bodyPr wrap="square" lIns="0" tIns="0" rIns="0" bIns="0" rtlCol="0" anchor="ctr"/>
           <a:lstStyle/>
           <a:p>
-            <a:pPr algn="ctr" indent="0" marL="0">
+            <a:pPr marL="0" indent="0" algn="ctr">
               <a:buNone/>
             </a:pPr>
             <a:r>
@@ -4370,7 +4273,7 @@
           <a:bodyPr wrap="square" lIns="0" tIns="0" rIns="0" bIns="0" rtlCol="0" anchor="t"/>
           <a:lstStyle/>
           <a:p>
-            <a:pPr algn="ctr" indent="0" marL="0">
+            <a:pPr marL="0" indent="0" algn="ctr">
               <a:buNone/>
             </a:pPr>
             <a:r>
@@ -4406,7 +4309,7 @@
           <a:bodyPr wrap="square" lIns="0" tIns="0" rIns="0" bIns="0" rtlCol="0" anchor="t"/>
           <a:lstStyle/>
           <a:p>
-            <a:pPr algn="ctr" indent="0" marL="0">
+            <a:pPr marL="0" indent="0" algn="ctr">
               <a:buNone/>
             </a:pPr>
             <a:r>
@@ -4442,7 +4345,7 @@
           <a:bodyPr wrap="square" lIns="0" tIns="0" rIns="0" bIns="0" rtlCol="0" anchor="t"/>
           <a:lstStyle/>
           <a:p>
-            <a:pPr algn="ctr" indent="0" marL="0">
+            <a:pPr marL="0" indent="0" algn="ctr">
               <a:buNone/>
             </a:pPr>
             <a:r>
@@ -4481,6 +4384,13 @@
             <a:prstDash val="solid"/>
           </a:ln>
         </p:spPr>
+        <p:txBody>
+          <a:bodyPr/>
+          <a:lstStyle/>
+          <a:p>
+            <a:endParaRPr lang="es-CO"/>
+          </a:p>
+        </p:txBody>
       </p:sp>
       <p:sp>
         <p:nvSpPr>
@@ -4503,7 +4413,7 @@
           <a:bodyPr wrap="square" lIns="0" tIns="0" rIns="0" bIns="0" rtlCol="0" anchor="ctr"/>
           <a:lstStyle/>
           <a:p>
-            <a:pPr algn="ctr" indent="0" marL="0">
+            <a:pPr marL="0" indent="0" algn="ctr">
               <a:buNone/>
             </a:pPr>
             <a:r>
@@ -4539,7 +4449,7 @@
           <a:bodyPr wrap="square" lIns="0" tIns="0" rIns="0" bIns="0" rtlCol="0" anchor="t"/>
           <a:lstStyle/>
           <a:p>
-            <a:pPr algn="ctr" indent="0" marL="0">
+            <a:pPr marL="0" indent="0" algn="ctr">
               <a:buNone/>
             </a:pPr>
             <a:r>
@@ -4575,7 +4485,7 @@
           <a:bodyPr wrap="square" lIns="0" tIns="0" rIns="0" bIns="0" rtlCol="0" anchor="t"/>
           <a:lstStyle/>
           <a:p>
-            <a:pPr algn="ctr" indent="0" marL="0">
+            <a:pPr marL="0" indent="0" algn="ctr">
               <a:buNone/>
             </a:pPr>
             <a:r>
@@ -4611,7 +4521,7 @@
           <a:bodyPr wrap="square" lIns="0" tIns="0" rIns="0" bIns="0" rtlCol="0" anchor="t"/>
           <a:lstStyle/>
           <a:p>
-            <a:pPr algn="ctr" indent="0" marL="0">
+            <a:pPr marL="0" indent="0" algn="ctr">
               <a:buNone/>
             </a:pPr>
             <a:r>
@@ -4650,6 +4560,13 @@
             <a:prstDash val="solid"/>
           </a:ln>
         </p:spPr>
+        <p:txBody>
+          <a:bodyPr/>
+          <a:lstStyle/>
+          <a:p>
+            <a:endParaRPr lang="es-CO"/>
+          </a:p>
+        </p:txBody>
       </p:sp>
       <p:sp>
         <p:nvSpPr>
@@ -4672,7 +4589,7 @@
           <a:bodyPr wrap="square" lIns="0" tIns="0" rIns="0" bIns="0" rtlCol="0" anchor="ctr"/>
           <a:lstStyle/>
           <a:p>
-            <a:pPr algn="ctr" indent="0" marL="0">
+            <a:pPr marL="0" indent="0" algn="ctr">
               <a:buNone/>
             </a:pPr>
             <a:r>
@@ -4708,7 +4625,7 @@
           <a:bodyPr wrap="square" lIns="0" tIns="0" rIns="0" bIns="0" rtlCol="0" anchor="t"/>
           <a:lstStyle/>
           <a:p>
-            <a:pPr algn="ctr" indent="0" marL="0">
+            <a:pPr marL="0" indent="0" algn="ctr">
               <a:buNone/>
             </a:pPr>
             <a:r>
@@ -4744,7 +4661,7 @@
           <a:bodyPr wrap="square" lIns="0" tIns="0" rIns="0" bIns="0" rtlCol="0" anchor="t"/>
           <a:lstStyle/>
           <a:p>
-            <a:pPr algn="ctr" indent="0" marL="0">
+            <a:pPr marL="0" indent="0" algn="ctr">
               <a:buNone/>
             </a:pPr>
             <a:r>
@@ -4780,7 +4697,7 @@
           <a:bodyPr wrap="square" lIns="0" tIns="0" rIns="0" bIns="0" rtlCol="0" anchor="t"/>
           <a:lstStyle/>
           <a:p>
-            <a:pPr algn="ctr" indent="0" marL="0">
+            <a:pPr marL="0" indent="0" algn="ctr">
               <a:buNone/>
             </a:pPr>
             <a:r>
@@ -4819,6 +4736,13 @@
             <a:prstDash val="solid"/>
           </a:ln>
         </p:spPr>
+        <p:txBody>
+          <a:bodyPr/>
+          <a:lstStyle/>
+          <a:p>
+            <a:endParaRPr lang="es-CO"/>
+          </a:p>
+        </p:txBody>
       </p:sp>
       <p:sp>
         <p:nvSpPr>
@@ -4841,7 +4765,7 @@
           <a:bodyPr wrap="square" lIns="0" tIns="0" rIns="0" bIns="0" rtlCol="0" anchor="ctr"/>
           <a:lstStyle/>
           <a:p>
-            <a:pPr algn="ctr" indent="0" marL="0">
+            <a:pPr marL="0" indent="0" algn="ctr">
               <a:buNone/>
             </a:pPr>
             <a:r>
@@ -4877,7 +4801,7 @@
           <a:bodyPr wrap="square" lIns="0" tIns="0" rIns="0" bIns="0" rtlCol="0" anchor="t"/>
           <a:lstStyle/>
           <a:p>
-            <a:pPr algn="ctr" indent="0" marL="0">
+            <a:pPr marL="0" indent="0" algn="ctr">
               <a:buNone/>
             </a:pPr>
             <a:r>
@@ -4913,7 +4837,7 @@
           <a:bodyPr wrap="square" lIns="0" tIns="0" rIns="0" bIns="0" rtlCol="0" anchor="t"/>
           <a:lstStyle/>
           <a:p>
-            <a:pPr algn="ctr" indent="0" marL="0">
+            <a:pPr marL="0" indent="0" algn="ctr">
               <a:buNone/>
             </a:pPr>
             <a:r>
@@ -4949,7 +4873,7 @@
           <a:bodyPr wrap="square" lIns="0" tIns="0" rIns="0" bIns="0" rtlCol="0" anchor="t"/>
           <a:lstStyle/>
           <a:p>
-            <a:pPr algn="ctr" indent="0" marL="0">
+            <a:pPr marL="0" indent="0" algn="ctr">
               <a:buNone/>
             </a:pPr>
             <a:r>
@@ -4985,7 +4909,7 @@
           <a:bodyPr wrap="square" lIns="0" tIns="0" rIns="0" bIns="0" rtlCol="0" anchor="t"/>
           <a:lstStyle/>
           <a:p>
-            <a:pPr indent="0" marL="0">
+            <a:pPr marL="0" indent="0">
               <a:buNone/>
             </a:pPr>
             <a:r>
@@ -4996,9 +4920,6 @@
               </a:rPr>
               <a:t>Verde: </a:t>
             </a:r>
-            <a:pPr indent="0" marL="0">
-              <a:buNone/>
-            </a:pPr>
             <a:r>
               <a:rPr lang="en-US" sz="1100" dirty="0">
                 <a:solidFill>
@@ -5007,9 +4928,6 @@
               </a:rPr>
               <a:t>completado y aprobado   </a:t>
             </a:r>
-            <a:pPr indent="0" marL="0">
-              <a:buNone/>
-            </a:pPr>
             <a:r>
               <a:rPr lang="en-US" sz="1100" b="1" dirty="0">
                 <a:solidFill>
@@ -5018,9 +4936,6 @@
               </a:rPr>
               <a:t>Ámbar: </a:t>
             </a:r>
-            <a:pPr indent="0" marL="0">
-              <a:buNone/>
-            </a:pPr>
             <a:r>
               <a:rPr lang="en-US" sz="1100" dirty="0">
                 <a:solidFill>
@@ -5035,7 +4950,7 @@
       </p:sp>
       <p:sp>
         <p:nvSpPr>
-          <p:cNvPr id="25" name="Slide Number Placeholder 0"/>
+          <p:cNvPr id="30" name="Slide Number Placeholder 0"/>
           <p:cNvSpPr>
             <a:spLocks noGrp="1"/>
           </p:cNvSpPr>
@@ -5053,7 +4968,7 @@
           </a:prstGeom>
           <a:extLst>
             <a:ext uri="{C572A759-6A51-4108-AA02-DFA0A04FC94B}">
-              <ma14:wrappingTextBoxFlag xmlns:ma14="http://schemas.microsoft.com/office/mac/drawingml/2011/main" val="0"/>
+              <ma14:wrappingTextBoxFlag xmlns:ma14="http://schemas.microsoft.com/office/mac/drawingml/2011/main" xmlns="" val="0"/>
             </a:ext>
           </a:extLst>
         </p:spPr>
@@ -5071,7 +4986,7 @@
           <a:p>
             <a:pPr algn="r"/>
             <a:fld id="{F7021451-1387-4CA6-816F-3879F97B5CBC}" type="slidenum">
-              <a:rPr b="0" lang="en-US"/>
+              <a:rPr lang="en-US" b="0"/>
               <a:t>11</a:t>
             </a:fld>
             <a:endParaRPr lang="en-US"/>
@@ -5106,9 +5021,11 @@
       <p:sp>
         <p:nvSpPr>
           <p:cNvPr id="2" name="Text 0"/>
-          <p:cNvSpPr/>
+          <p:cNvSpPr>
+            <a:spLocks noGrp="1"/>
+          </p:cNvSpPr>
           <p:nvPr>
-            <p:ph idx="100" type="title" hasCustomPrompt="1"/>
+            <p:ph type="title" idx="100" hasCustomPrompt="1"/>
           </p:nvPr>
         </p:nvSpPr>
         <p:spPr>
@@ -5126,7 +5043,7 @@
           <a:bodyPr wrap="square" lIns="0" tIns="0" rIns="0" bIns="0" rtlCol="0" anchor="ctr"/>
           <a:lstStyle/>
           <a:p>
-            <a:pPr indent="0" marL="0">
+            <a:pPr marL="0" indent="0">
               <a:buNone/>
             </a:pPr>
             <a:r>
@@ -5170,6 +5087,13 @@
             <a:prstDash val="solid"/>
           </a:ln>
         </p:spPr>
+        <p:txBody>
+          <a:bodyPr/>
+          <a:lstStyle/>
+          <a:p>
+            <a:endParaRPr lang="es-CO"/>
+          </a:p>
+        </p:txBody>
       </p:sp>
       <p:sp>
         <p:nvSpPr>
@@ -5192,7 +5116,7 @@
           <a:bodyPr wrap="square" lIns="0" tIns="0" rIns="0" bIns="0" rtlCol="0" anchor="t"/>
           <a:lstStyle/>
           <a:p>
-            <a:pPr indent="0" marL="0">
+            <a:pPr marL="0" indent="0">
               <a:buNone/>
             </a:pPr>
             <a:r>
@@ -5340,7 +5264,7 @@
           <a:bodyPr wrap="square" lIns="0" tIns="0" rIns="0" bIns="0" rtlCol="0" anchor="t"/>
           <a:lstStyle/>
           <a:p>
-            <a:pPr indent="0" marL="0">
+            <a:pPr marL="0" indent="0">
               <a:buNone/>
             </a:pPr>
             <a:r>
@@ -5371,15 +5295,27 @@
         </p:nvGraphicFramePr>
         <p:xfrm>
           <a:off x="4572000" y="1188720"/>
-          <a:ext cx="4114800" cy="914400"/>
+          <a:ext cx="4114800" cy="2304288"/>
         </p:xfrm>
         <a:graphic>
           <a:graphicData uri="http://schemas.openxmlformats.org/drawingml/2006/table">
             <a:tbl>
               <a:tblPr/>
               <a:tblGrid>
-                <a:gridCol w="2926080"/>
-                <a:gridCol w="1188720"/>
+                <a:gridCol w="2926080">
+                  <a:extLst>
+                    <a:ext uri="{9D8B030D-6E8A-4147-A177-3AD203B41FA5}">
+                      <a16:colId xmlns:a16="http://schemas.microsoft.com/office/drawing/2014/main" val="20000"/>
+                    </a:ext>
+                  </a:extLst>
+                </a:gridCol>
+                <a:gridCol w="1188720">
+                  <a:extLst>
+                    <a:ext uri="{9D8B030D-6E8A-4147-A177-3AD203B41FA5}">
+                      <a16:colId xmlns:a16="http://schemas.microsoft.com/office/drawing/2014/main" val="20001"/>
+                    </a:ext>
+                  </a:extLst>
+                </a:gridCol>
               </a:tblGrid>
               <a:tr h="384048">
                 <a:tc>
@@ -5387,7 +5323,7 @@
                     <a:bodyPr/>
                     <a:lstStyle/>
                     <a:p>
-                      <a:pPr indent="0" marL="0">
+                      <a:pPr marL="0" indent="0">
                         <a:buNone/>
                       </a:pPr>
                       <a:r>
@@ -5401,7 +5337,7 @@
                       <a:endParaRPr lang="en-US" sz="1100" dirty="0"/>
                     </a:p>
                   </a:txBody>
-                  <a:tcPr marL="91440" marR="91440" marT="45720" marB="45720" anchor="ctr">
+                  <a:tcPr anchor="ctr">
                     <a:lnL w="6350" cap="flat" cmpd="sng" algn="ctr">
                       <a:solidFill>
                         <a:srgbClr val="DCE6E4"/>
@@ -5448,7 +5384,7 @@
                     <a:bodyPr/>
                     <a:lstStyle/>
                     <a:p>
-                      <a:pPr indent="0" marL="0">
+                      <a:pPr marL="0" indent="0">
                         <a:buNone/>
                       </a:pPr>
                       <a:r>
@@ -5462,7 +5398,7 @@
                       <a:endParaRPr lang="en-US" sz="1100" dirty="0"/>
                     </a:p>
                   </a:txBody>
-                  <a:tcPr marL="91440" marR="91440" marT="45720" marB="45720" anchor="ctr">
+                  <a:tcPr anchor="ctr">
                     <a:lnL w="6350" cap="flat" cmpd="sng" algn="ctr">
                       <a:solidFill>
                         <a:srgbClr val="DCE6E4"/>
@@ -5504,6 +5440,11 @@
                     </a:solidFill>
                   </a:tcPr>
                 </a:tc>
+                <a:extLst>
+                  <a:ext uri="{0D108BD9-81ED-4DB2-BD59-A6C34878D82A}">
+                    <a16:rowId xmlns:a16="http://schemas.microsoft.com/office/drawing/2014/main" val="10000"/>
+                  </a:ext>
+                </a:extLst>
               </a:tr>
               <a:tr h="384048">
                 <a:tc>
@@ -5511,7 +5452,7 @@
                     <a:bodyPr/>
                     <a:lstStyle/>
                     <a:p>
-                      <a:pPr indent="0" marL="0">
+                      <a:pPr marL="0" indent="0">
                         <a:buNone/>
                       </a:pPr>
                       <a:r>
@@ -5525,7 +5466,7 @@
                       <a:endParaRPr lang="en-US" sz="1100" dirty="0"/>
                     </a:p>
                   </a:txBody>
-                  <a:tcPr marL="91440" marR="91440" marT="45720" marB="45720" anchor="ctr">
+                  <a:tcPr anchor="ctr">
                     <a:lnL w="6350" cap="flat" cmpd="sng" algn="ctr">
                       <a:solidFill>
                         <a:srgbClr val="DCE6E4"/>
@@ -5569,7 +5510,7 @@
                     <a:bodyPr/>
                     <a:lstStyle/>
                     <a:p>
-                      <a:pPr indent="0" marL="0">
+                      <a:pPr marL="0" indent="0">
                         <a:buNone/>
                       </a:pPr>
                       <a:r>
@@ -5583,7 +5524,7 @@
                       <a:endParaRPr lang="en-US" sz="1100" dirty="0"/>
                     </a:p>
                   </a:txBody>
-                  <a:tcPr marL="91440" marR="91440" marT="45720" marB="45720" anchor="ctr">
+                  <a:tcPr anchor="ctr">
                     <a:lnL w="6350" cap="flat" cmpd="sng" algn="ctr">
                       <a:solidFill>
                         <a:srgbClr val="DCE6E4"/>
@@ -5622,6 +5563,11 @@
                     </a:lnB>
                   </a:tcPr>
                 </a:tc>
+                <a:extLst>
+                  <a:ext uri="{0D108BD9-81ED-4DB2-BD59-A6C34878D82A}">
+                    <a16:rowId xmlns:a16="http://schemas.microsoft.com/office/drawing/2014/main" val="10001"/>
+                  </a:ext>
+                </a:extLst>
               </a:tr>
               <a:tr h="384048">
                 <a:tc>
@@ -5629,7 +5575,7 @@
                     <a:bodyPr/>
                     <a:lstStyle/>
                     <a:p>
-                      <a:pPr indent="0" marL="0">
+                      <a:pPr marL="0" indent="0">
                         <a:buNone/>
                       </a:pPr>
                       <a:r>
@@ -5643,7 +5589,7 @@
                       <a:endParaRPr lang="en-US" sz="1100" dirty="0"/>
                     </a:p>
                   </a:txBody>
-                  <a:tcPr marL="91440" marR="91440" marT="45720" marB="45720" anchor="ctr">
+                  <a:tcPr anchor="ctr">
                     <a:lnL w="6350" cap="flat" cmpd="sng" algn="ctr">
                       <a:solidFill>
                         <a:srgbClr val="DCE6E4"/>
@@ -5687,7 +5633,7 @@
                     <a:bodyPr/>
                     <a:lstStyle/>
                     <a:p>
-                      <a:pPr indent="0" marL="0">
+                      <a:pPr marL="0" indent="0">
                         <a:buNone/>
                       </a:pPr>
                       <a:r>
@@ -5701,7 +5647,7 @@
                       <a:endParaRPr lang="en-US" sz="1100" dirty="0"/>
                     </a:p>
                   </a:txBody>
-                  <a:tcPr marL="91440" marR="91440" marT="45720" marB="45720" anchor="ctr">
+                  <a:tcPr anchor="ctr">
                     <a:lnL w="6350" cap="flat" cmpd="sng" algn="ctr">
                       <a:solidFill>
                         <a:srgbClr val="DCE6E4"/>
@@ -5740,6 +5686,11 @@
                     </a:lnB>
                   </a:tcPr>
                 </a:tc>
+                <a:extLst>
+                  <a:ext uri="{0D108BD9-81ED-4DB2-BD59-A6C34878D82A}">
+                    <a16:rowId xmlns:a16="http://schemas.microsoft.com/office/drawing/2014/main" val="10002"/>
+                  </a:ext>
+                </a:extLst>
               </a:tr>
               <a:tr h="384048">
                 <a:tc>
@@ -5747,7 +5698,7 @@
                     <a:bodyPr/>
                     <a:lstStyle/>
                     <a:p>
-                      <a:pPr indent="0" marL="0">
+                      <a:pPr marL="0" indent="0">
                         <a:buNone/>
                       </a:pPr>
                       <a:r>
@@ -5761,7 +5712,7 @@
                       <a:endParaRPr lang="en-US" sz="1100" dirty="0"/>
                     </a:p>
                   </a:txBody>
-                  <a:tcPr marL="91440" marR="91440" marT="45720" marB="45720" anchor="ctr">
+                  <a:tcPr anchor="ctr">
                     <a:lnL w="6350" cap="flat" cmpd="sng" algn="ctr">
                       <a:solidFill>
                         <a:srgbClr val="DCE6E4"/>
@@ -5805,7 +5756,7 @@
                     <a:bodyPr/>
                     <a:lstStyle/>
                     <a:p>
-                      <a:pPr indent="0" marL="0">
+                      <a:pPr marL="0" indent="0">
                         <a:buNone/>
                       </a:pPr>
                       <a:r>
@@ -5819,7 +5770,7 @@
                       <a:endParaRPr lang="en-US" sz="1100" dirty="0"/>
                     </a:p>
                   </a:txBody>
-                  <a:tcPr marL="91440" marR="91440" marT="45720" marB="45720" anchor="ctr">
+                  <a:tcPr anchor="ctr">
                     <a:lnL w="6350" cap="flat" cmpd="sng" algn="ctr">
                       <a:solidFill>
                         <a:srgbClr val="DCE6E4"/>
@@ -5858,6 +5809,11 @@
                     </a:lnB>
                   </a:tcPr>
                 </a:tc>
+                <a:extLst>
+                  <a:ext uri="{0D108BD9-81ED-4DB2-BD59-A6C34878D82A}">
+                    <a16:rowId xmlns:a16="http://schemas.microsoft.com/office/drawing/2014/main" val="10003"/>
+                  </a:ext>
+                </a:extLst>
               </a:tr>
               <a:tr h="384048">
                 <a:tc>
@@ -5865,7 +5821,7 @@
                     <a:bodyPr/>
                     <a:lstStyle/>
                     <a:p>
-                      <a:pPr indent="0" marL="0">
+                      <a:pPr marL="0" indent="0">
                         <a:buNone/>
                       </a:pPr>
                       <a:r>
@@ -5879,7 +5835,7 @@
                       <a:endParaRPr lang="en-US" sz="1100" dirty="0"/>
                     </a:p>
                   </a:txBody>
-                  <a:tcPr marL="91440" marR="91440" marT="45720" marB="45720" anchor="ctr">
+                  <a:tcPr anchor="ctr">
                     <a:lnL w="6350" cap="flat" cmpd="sng" algn="ctr">
                       <a:solidFill>
                         <a:srgbClr val="DCE6E4"/>
@@ -5923,7 +5879,7 @@
                     <a:bodyPr/>
                     <a:lstStyle/>
                     <a:p>
-                      <a:pPr indent="0" marL="0">
+                      <a:pPr marL="0" indent="0">
                         <a:buNone/>
                       </a:pPr>
                       <a:r>
@@ -5937,7 +5893,7 @@
                       <a:endParaRPr lang="en-US" sz="1100" dirty="0"/>
                     </a:p>
                   </a:txBody>
-                  <a:tcPr marL="91440" marR="91440" marT="45720" marB="45720" anchor="ctr">
+                  <a:tcPr anchor="ctr">
                     <a:lnL w="6350" cap="flat" cmpd="sng" algn="ctr">
                       <a:solidFill>
                         <a:srgbClr val="DCE6E4"/>
@@ -5976,6 +5932,11 @@
                     </a:lnB>
                   </a:tcPr>
                 </a:tc>
+                <a:extLst>
+                  <a:ext uri="{0D108BD9-81ED-4DB2-BD59-A6C34878D82A}">
+                    <a16:rowId xmlns:a16="http://schemas.microsoft.com/office/drawing/2014/main" val="10004"/>
+                  </a:ext>
+                </a:extLst>
               </a:tr>
               <a:tr h="384048">
                 <a:tc>
@@ -5983,7 +5944,7 @@
                     <a:bodyPr/>
                     <a:lstStyle/>
                     <a:p>
-                      <a:pPr indent="0" marL="0">
+                      <a:pPr marL="0" indent="0">
                         <a:buNone/>
                       </a:pPr>
                       <a:r>
@@ -5997,7 +5958,7 @@
                       <a:endParaRPr lang="en-US" sz="1100" dirty="0"/>
                     </a:p>
                   </a:txBody>
-                  <a:tcPr marL="91440" marR="91440" marT="45720" marB="45720" anchor="ctr">
+                  <a:tcPr anchor="ctr">
                     <a:lnL w="6350" cap="flat" cmpd="sng" algn="ctr">
                       <a:solidFill>
                         <a:srgbClr val="DCE6E4"/>
@@ -6041,7 +6002,7 @@
                     <a:bodyPr/>
                     <a:lstStyle/>
                     <a:p>
-                      <a:pPr indent="0" marL="0">
+                      <a:pPr marL="0" indent="0">
                         <a:buNone/>
                       </a:pPr>
                       <a:r>
@@ -6055,7 +6016,7 @@
                       <a:endParaRPr lang="en-US" sz="1100" dirty="0"/>
                     </a:p>
                   </a:txBody>
-                  <a:tcPr marL="91440" marR="91440" marT="45720" marB="45720" anchor="ctr">
+                  <a:tcPr anchor="ctr">
                     <a:lnL w="6350" cap="flat" cmpd="sng" algn="ctr">
                       <a:solidFill>
                         <a:srgbClr val="DCE6E4"/>
@@ -6094,6 +6055,11 @@
                     </a:lnB>
                   </a:tcPr>
                 </a:tc>
+                <a:extLst>
+                  <a:ext uri="{0D108BD9-81ED-4DB2-BD59-A6C34878D82A}">
+                    <a16:rowId xmlns:a16="http://schemas.microsoft.com/office/drawing/2014/main" val="10005"/>
+                  </a:ext>
+                </a:extLst>
               </a:tr>
             </a:tbl>
           </a:graphicData>
@@ -6120,7 +6086,7 @@
           <a:bodyPr wrap="square" lIns="0" tIns="0" rIns="0" bIns="0" rtlCol="0" anchor="t"/>
           <a:lstStyle/>
           <a:p>
-            <a:pPr indent="0" marL="0">
+            <a:pPr marL="0" indent="0">
               <a:buNone/>
             </a:pPr>
             <a:r>
@@ -6155,7 +6121,7 @@
           </a:prstGeom>
           <a:extLst>
             <a:ext uri="{C572A759-6A51-4108-AA02-DFA0A04FC94B}">
-              <ma14:wrappingTextBoxFlag xmlns:ma14="http://schemas.microsoft.com/office/mac/drawingml/2011/main" val="0"/>
+              <ma14:wrappingTextBoxFlag xmlns:ma14="http://schemas.microsoft.com/office/mac/drawingml/2011/main" xmlns="" val="0"/>
             </a:ext>
           </a:extLst>
         </p:spPr>
@@ -6173,7 +6139,7 @@
           <a:p>
             <a:pPr algn="r"/>
             <a:fld id="{F7021451-1387-4CA6-816F-3879F97B5CBC}" type="slidenum">
-              <a:rPr b="0" lang="en-US"/>
+              <a:rPr lang="en-US" b="0"/>
               <a:t>12</a:t>
             </a:fld>
             <a:endParaRPr lang="en-US"/>
@@ -6208,9 +6174,11 @@
       <p:sp>
         <p:nvSpPr>
           <p:cNvPr id="2" name="Text 0"/>
-          <p:cNvSpPr/>
+          <p:cNvSpPr>
+            <a:spLocks noGrp="1"/>
+          </p:cNvSpPr>
           <p:nvPr>
-            <p:ph idx="100" type="title" hasCustomPrompt="1"/>
+            <p:ph type="title" idx="100" hasCustomPrompt="1"/>
           </p:nvPr>
         </p:nvSpPr>
         <p:spPr>
@@ -6228,7 +6196,7 @@
           <a:bodyPr wrap="square" lIns="0" tIns="0" rIns="0" bIns="0" rtlCol="0" anchor="b"/>
           <a:lstStyle/>
           <a:p>
-            <a:pPr indent="0" marL="0">
+            <a:pPr marL="0" indent="0">
               <a:buNone/>
             </a:pPr>
             <a:r>
@@ -6270,6 +6238,13 @@
             <a:prstDash val="solid"/>
           </a:ln>
         </p:spPr>
+        <p:txBody>
+          <a:bodyPr/>
+          <a:lstStyle/>
+          <a:p>
+            <a:endParaRPr lang="es-CO"/>
+          </a:p>
+        </p:txBody>
       </p:sp>
       <p:sp>
         <p:nvSpPr>
@@ -6292,7 +6267,7 @@
           <a:bodyPr wrap="square" lIns="0" tIns="0" rIns="0" bIns="0" rtlCol="0" anchor="ctr"/>
           <a:lstStyle/>
           <a:p>
-            <a:pPr algn="ctr" indent="0" marL="0">
+            <a:pPr marL="0" indent="0" algn="ctr">
               <a:buNone/>
             </a:pPr>
             <a:r>
@@ -6328,7 +6303,7 @@
           <a:bodyPr wrap="square" lIns="0" tIns="0" rIns="0" bIns="0" rtlCol="0" anchor="ctr"/>
           <a:lstStyle/>
           <a:p>
-            <a:pPr indent="0" marL="0">
+            <a:pPr marL="0" indent="0">
               <a:buNone/>
             </a:pPr>
             <a:r>
@@ -6364,7 +6339,7 @@
           <a:bodyPr wrap="square" lIns="0" tIns="0" rIns="0" bIns="0" rtlCol="0" anchor="t"/>
           <a:lstStyle/>
           <a:p>
-            <a:pPr indent="0" marL="0">
+            <a:pPr marL="0" indent="0">
               <a:buNone/>
             </a:pPr>
             <a:r>
@@ -6403,6 +6378,13 @@
             <a:prstDash val="solid"/>
           </a:ln>
         </p:spPr>
+        <p:txBody>
+          <a:bodyPr/>
+          <a:lstStyle/>
+          <a:p>
+            <a:endParaRPr lang="es-CO"/>
+          </a:p>
+        </p:txBody>
       </p:sp>
       <p:sp>
         <p:nvSpPr>
@@ -6425,7 +6407,7 @@
           <a:bodyPr wrap="square" lIns="0" tIns="0" rIns="0" bIns="0" rtlCol="0" anchor="ctr"/>
           <a:lstStyle/>
           <a:p>
-            <a:pPr algn="ctr" indent="0" marL="0">
+            <a:pPr marL="0" indent="0" algn="ctr">
               <a:buNone/>
             </a:pPr>
             <a:r>
@@ -6461,7 +6443,7 @@
           <a:bodyPr wrap="square" lIns="0" tIns="0" rIns="0" bIns="0" rtlCol="0" anchor="ctr"/>
           <a:lstStyle/>
           <a:p>
-            <a:pPr indent="0" marL="0">
+            <a:pPr marL="0" indent="0">
               <a:buNone/>
             </a:pPr>
             <a:r>
@@ -6497,7 +6479,7 @@
           <a:bodyPr wrap="square" lIns="0" tIns="0" rIns="0" bIns="0" rtlCol="0" anchor="t"/>
           <a:lstStyle/>
           <a:p>
-            <a:pPr indent="0" marL="0">
+            <a:pPr marL="0" indent="0">
               <a:buNone/>
             </a:pPr>
             <a:r>
@@ -6536,6 +6518,13 @@
             <a:prstDash val="solid"/>
           </a:ln>
         </p:spPr>
+        <p:txBody>
+          <a:bodyPr/>
+          <a:lstStyle/>
+          <a:p>
+            <a:endParaRPr lang="es-CO"/>
+          </a:p>
+        </p:txBody>
       </p:sp>
       <p:sp>
         <p:nvSpPr>
@@ -6558,7 +6547,7 @@
           <a:bodyPr wrap="square" lIns="0" tIns="0" rIns="0" bIns="0" rtlCol="0" anchor="ctr"/>
           <a:lstStyle/>
           <a:p>
-            <a:pPr algn="ctr" indent="0" marL="0">
+            <a:pPr marL="0" indent="0" algn="ctr">
               <a:buNone/>
             </a:pPr>
             <a:r>
@@ -6594,7 +6583,7 @@
           <a:bodyPr wrap="square" lIns="0" tIns="0" rIns="0" bIns="0" rtlCol="0" anchor="ctr"/>
           <a:lstStyle/>
           <a:p>
-            <a:pPr indent="0" marL="0">
+            <a:pPr marL="0" indent="0">
               <a:buNone/>
             </a:pPr>
             <a:r>
@@ -6630,7 +6619,7 @@
           <a:bodyPr wrap="square" lIns="0" tIns="0" rIns="0" bIns="0" rtlCol="0" anchor="t"/>
           <a:lstStyle/>
           <a:p>
-            <a:pPr indent="0" marL="0">
+            <a:pPr marL="0" indent="0">
               <a:buNone/>
             </a:pPr>
             <a:r>
@@ -6673,9 +6662,11 @@
       <p:sp>
         <p:nvSpPr>
           <p:cNvPr id="2" name="Text 0"/>
-          <p:cNvSpPr/>
+          <p:cNvSpPr>
+            <a:spLocks noGrp="1"/>
+          </p:cNvSpPr>
           <p:nvPr>
-            <p:ph idx="100" type="title" hasCustomPrompt="1"/>
+            <p:ph type="title" idx="100" hasCustomPrompt="1"/>
           </p:nvPr>
         </p:nvSpPr>
         <p:spPr>
@@ -6693,7 +6684,7 @@
           <a:bodyPr wrap="square" lIns="0" tIns="0" rIns="0" bIns="0" rtlCol="0" anchor="ctr"/>
           <a:lstStyle/>
           <a:p>
-            <a:pPr indent="0" marL="0">
+            <a:pPr marL="0" indent="0">
               <a:buNone/>
             </a:pPr>
             <a:r>
@@ -6737,6 +6728,13 @@
             <a:prstDash val="solid"/>
           </a:ln>
         </p:spPr>
+        <p:txBody>
+          <a:bodyPr/>
+          <a:lstStyle/>
+          <a:p>
+            <a:endParaRPr lang="es-CO"/>
+          </a:p>
+        </p:txBody>
       </p:sp>
       <p:sp>
         <p:nvSpPr>
@@ -6759,7 +6757,7 @@
           <a:bodyPr wrap="square" lIns="0" tIns="0" rIns="0" bIns="0" rtlCol="0" anchor="ctr"/>
           <a:lstStyle/>
           <a:p>
-            <a:pPr indent="0" marL="0">
+            <a:pPr marL="0" indent="0">
               <a:buNone/>
             </a:pPr>
             <a:r>
@@ -6798,7 +6796,7 @@
           <a:bodyPr wrap="square" lIns="0" tIns="0" rIns="0" bIns="0" rtlCol="0" anchor="t"/>
           <a:lstStyle/>
           <a:p>
-            <a:pPr indent="0" marL="0">
+            <a:pPr marL="0" indent="0">
               <a:buNone/>
             </a:pPr>
             <a:r>
@@ -6834,7 +6832,7 @@
           <a:bodyPr wrap="square" lIns="0" tIns="0" rIns="0" bIns="0" rtlCol="0" anchor="t"/>
           <a:lstStyle/>
           <a:p>
-            <a:pPr indent="0" marL="0">
+            <a:pPr marL="0" indent="0">
               <a:buNone/>
             </a:pPr>
             <a:r>
@@ -6875,6 +6873,13 @@
             <a:prstDash val="solid"/>
           </a:ln>
         </p:spPr>
+        <p:txBody>
+          <a:bodyPr/>
+          <a:lstStyle/>
+          <a:p>
+            <a:endParaRPr lang="es-CO"/>
+          </a:p>
+        </p:txBody>
       </p:sp>
       <p:sp>
         <p:nvSpPr>
@@ -6897,7 +6902,7 @@
           <a:bodyPr wrap="square" lIns="0" tIns="0" rIns="0" bIns="0" rtlCol="0" anchor="ctr"/>
           <a:lstStyle/>
           <a:p>
-            <a:pPr indent="0" marL="0">
+            <a:pPr marL="0" indent="0">
               <a:buNone/>
             </a:pPr>
             <a:r>
@@ -6936,7 +6941,7 @@
           <a:bodyPr wrap="square" lIns="0" tIns="0" rIns="0" bIns="0" rtlCol="0" anchor="t"/>
           <a:lstStyle/>
           <a:p>
-            <a:pPr indent="0" marL="0">
+            <a:pPr marL="0" indent="0">
               <a:buNone/>
             </a:pPr>
             <a:r>
@@ -6972,7 +6977,7 @@
           <a:bodyPr wrap="square" lIns="0" tIns="0" rIns="0" bIns="0" rtlCol="0" anchor="t"/>
           <a:lstStyle/>
           <a:p>
-            <a:pPr indent="0" marL="0">
+            <a:pPr marL="0" indent="0">
               <a:buNone/>
             </a:pPr>
             <a:r>
@@ -7013,6 +7018,13 @@
             <a:prstDash val="solid"/>
           </a:ln>
         </p:spPr>
+        <p:txBody>
+          <a:bodyPr/>
+          <a:lstStyle/>
+          <a:p>
+            <a:endParaRPr lang="es-CO"/>
+          </a:p>
+        </p:txBody>
       </p:sp>
       <p:sp>
         <p:nvSpPr>
@@ -7035,7 +7047,7 @@
           <a:bodyPr wrap="square" lIns="0" tIns="0" rIns="0" bIns="0" rtlCol="0" anchor="ctr"/>
           <a:lstStyle/>
           <a:p>
-            <a:pPr indent="0" marL="0">
+            <a:pPr marL="0" indent="0">
               <a:buNone/>
             </a:pPr>
             <a:r>
@@ -7074,7 +7086,7 @@
           <a:bodyPr wrap="square" lIns="0" tIns="0" rIns="0" bIns="0" rtlCol="0" anchor="t"/>
           <a:lstStyle/>
           <a:p>
-            <a:pPr indent="0" marL="0">
+            <a:pPr marL="0" indent="0">
               <a:buNone/>
             </a:pPr>
             <a:r>
@@ -7110,7 +7122,7 @@
           <a:bodyPr wrap="square" lIns="0" tIns="0" rIns="0" bIns="0" rtlCol="0" anchor="t"/>
           <a:lstStyle/>
           <a:p>
-            <a:pPr indent="0" marL="0">
+            <a:pPr marL="0" indent="0">
               <a:buNone/>
             </a:pPr>
             <a:r>
@@ -7146,7 +7158,7 @@
           <a:bodyPr wrap="square" lIns="0" tIns="0" rIns="0" bIns="0" rtlCol="0" anchor="t"/>
           <a:lstStyle/>
           <a:p>
-            <a:pPr indent="0" marL="0">
+            <a:pPr marL="0" indent="0">
               <a:buNone/>
             </a:pPr>
             <a:r>
@@ -7157,9 +7169,6 @@
               </a:rPr>
               <a:t>Cómo: </a:t>
             </a:r>
-            <a:pPr indent="0" marL="0">
-              <a:buNone/>
-            </a:pPr>
             <a:r>
               <a:rPr lang="en-US" sz="1400" dirty="0">
                 <a:solidFill>
@@ -7192,7 +7201,7 @@
           </a:prstGeom>
           <a:extLst>
             <a:ext uri="{C572A759-6A51-4108-AA02-DFA0A04FC94B}">
-              <ma14:wrappingTextBoxFlag xmlns:ma14="http://schemas.microsoft.com/office/mac/drawingml/2011/main" val="0"/>
+              <ma14:wrappingTextBoxFlag xmlns:ma14="http://schemas.microsoft.com/office/mac/drawingml/2011/main" xmlns="" val="0"/>
             </a:ext>
           </a:extLst>
         </p:spPr>
@@ -7210,7 +7219,7 @@
           <a:p>
             <a:pPr algn="r"/>
             <a:fld id="{F7021451-1387-4CA6-816F-3879F97B5CBC}" type="slidenum">
-              <a:rPr b="0" lang="en-US"/>
+              <a:rPr lang="en-US" b="0"/>
               <a:t>2</a:t>
             </a:fld>
             <a:endParaRPr lang="en-US"/>
@@ -7245,9 +7254,11 @@
       <p:sp>
         <p:nvSpPr>
           <p:cNvPr id="2" name="Text 0"/>
-          <p:cNvSpPr/>
+          <p:cNvSpPr>
+            <a:spLocks noGrp="1"/>
+          </p:cNvSpPr>
           <p:nvPr>
-            <p:ph idx="100" type="title" hasCustomPrompt="1"/>
+            <p:ph type="title" idx="100" hasCustomPrompt="1"/>
           </p:nvPr>
         </p:nvSpPr>
         <p:spPr>
@@ -7265,7 +7276,7 @@
           <a:bodyPr wrap="square" lIns="0" tIns="0" rIns="0" bIns="0" rtlCol="0" anchor="ctr"/>
           <a:lstStyle/>
           <a:p>
-            <a:pPr indent="0" marL="0">
+            <a:pPr marL="0" indent="0">
               <a:buNone/>
             </a:pPr>
             <a:r>
@@ -7307,6 +7318,13 @@
             <a:prstDash val="solid"/>
           </a:ln>
         </p:spPr>
+        <p:txBody>
+          <a:bodyPr/>
+          <a:lstStyle/>
+          <a:p>
+            <a:endParaRPr lang="es-CO"/>
+          </a:p>
+        </p:txBody>
       </p:sp>
       <p:sp>
         <p:nvSpPr>
@@ -7329,7 +7347,7 @@
           <a:bodyPr wrap="square" lIns="0" tIns="0" rIns="0" bIns="0" rtlCol="0" anchor="t"/>
           <a:lstStyle/>
           <a:p>
-            <a:pPr algn="ctr" indent="0" marL="0">
+            <a:pPr marL="0" indent="0" algn="ctr">
               <a:buNone/>
             </a:pPr>
             <a:r>
@@ -7365,7 +7383,7 @@
           <a:bodyPr wrap="square" lIns="0" tIns="0" rIns="0" bIns="0" rtlCol="0" anchor="t"/>
           <a:lstStyle/>
           <a:p>
-            <a:pPr algn="ctr" indent="0" marL="0">
+            <a:pPr marL="0" indent="0" algn="ctr">
               <a:buNone/>
             </a:pPr>
             <a:r>
@@ -7404,6 +7422,13 @@
             <a:prstDash val="solid"/>
           </a:ln>
         </p:spPr>
+        <p:txBody>
+          <a:bodyPr/>
+          <a:lstStyle/>
+          <a:p>
+            <a:endParaRPr lang="es-CO"/>
+          </a:p>
+        </p:txBody>
       </p:sp>
       <p:sp>
         <p:nvSpPr>
@@ -7426,7 +7451,7 @@
           <a:bodyPr wrap="square" lIns="0" tIns="0" rIns="0" bIns="0" rtlCol="0" anchor="t"/>
           <a:lstStyle/>
           <a:p>
-            <a:pPr algn="ctr" indent="0" marL="0">
+            <a:pPr marL="0" indent="0" algn="ctr">
               <a:buNone/>
             </a:pPr>
             <a:r>
@@ -7462,7 +7487,7 @@
           <a:bodyPr wrap="square" lIns="0" tIns="0" rIns="0" bIns="0" rtlCol="0" anchor="t"/>
           <a:lstStyle/>
           <a:p>
-            <a:pPr algn="ctr" indent="0" marL="0">
+            <a:pPr marL="0" indent="0" algn="ctr">
               <a:buNone/>
             </a:pPr>
             <a:r>
@@ -7501,6 +7526,13 @@
             <a:prstDash val="solid"/>
           </a:ln>
         </p:spPr>
+        <p:txBody>
+          <a:bodyPr/>
+          <a:lstStyle/>
+          <a:p>
+            <a:endParaRPr lang="es-CO"/>
+          </a:p>
+        </p:txBody>
       </p:sp>
       <p:sp>
         <p:nvSpPr>
@@ -7523,7 +7555,7 @@
           <a:bodyPr wrap="square" lIns="0" tIns="0" rIns="0" bIns="0" rtlCol="0" anchor="t"/>
           <a:lstStyle/>
           <a:p>
-            <a:pPr algn="ctr" indent="0" marL="0">
+            <a:pPr marL="0" indent="0" algn="ctr">
               <a:buNone/>
             </a:pPr>
             <a:r>
@@ -7559,7 +7591,7 @@
           <a:bodyPr wrap="square" lIns="0" tIns="0" rIns="0" bIns="0" rtlCol="0" anchor="t"/>
           <a:lstStyle/>
           <a:p>
-            <a:pPr algn="ctr" indent="0" marL="0">
+            <a:pPr marL="0" indent="0" algn="ctr">
               <a:buNone/>
             </a:pPr>
             <a:r>
@@ -7598,6 +7630,13 @@
             <a:prstDash val="solid"/>
           </a:ln>
         </p:spPr>
+        <p:txBody>
+          <a:bodyPr/>
+          <a:lstStyle/>
+          <a:p>
+            <a:endParaRPr lang="es-CO"/>
+          </a:p>
+        </p:txBody>
       </p:sp>
       <p:sp>
         <p:nvSpPr>
@@ -7620,7 +7659,7 @@
           <a:bodyPr wrap="square" lIns="0" tIns="0" rIns="0" bIns="0" rtlCol="0" anchor="t"/>
           <a:lstStyle/>
           <a:p>
-            <a:pPr algn="ctr" indent="0" marL="0">
+            <a:pPr marL="0" indent="0" algn="ctr">
               <a:buNone/>
             </a:pPr>
             <a:r>
@@ -7656,7 +7695,7 @@
           <a:bodyPr wrap="square" lIns="0" tIns="0" rIns="0" bIns="0" rtlCol="0" anchor="t"/>
           <a:lstStyle/>
           <a:p>
-            <a:pPr algn="ctr" indent="0" marL="0">
+            <a:pPr marL="0" indent="0" algn="ctr">
               <a:buNone/>
             </a:pPr>
             <a:r>
@@ -7695,6 +7734,13 @@
             <a:prstDash val="solid"/>
           </a:ln>
         </p:spPr>
+        <p:txBody>
+          <a:bodyPr/>
+          <a:lstStyle/>
+          <a:p>
+            <a:endParaRPr lang="es-CO"/>
+          </a:p>
+        </p:txBody>
       </p:sp>
       <p:sp>
         <p:nvSpPr>
@@ -7717,7 +7763,7 @@
           <a:bodyPr wrap="square" lIns="0" tIns="0" rIns="0" bIns="0" rtlCol="0" anchor="t"/>
           <a:lstStyle/>
           <a:p>
-            <a:pPr algn="ctr" indent="0" marL="0">
+            <a:pPr marL="0" indent="0" algn="ctr">
               <a:buNone/>
             </a:pPr>
             <a:r>
@@ -7753,7 +7799,7 @@
           <a:bodyPr wrap="square" lIns="0" tIns="0" rIns="0" bIns="0" rtlCol="0" anchor="t"/>
           <a:lstStyle/>
           <a:p>
-            <a:pPr algn="ctr" indent="0" marL="0">
+            <a:pPr marL="0" indent="0" algn="ctr">
               <a:buNone/>
             </a:pPr>
             <a:r>
@@ -7792,6 +7838,13 @@
             <a:prstDash val="solid"/>
           </a:ln>
         </p:spPr>
+        <p:txBody>
+          <a:bodyPr/>
+          <a:lstStyle/>
+          <a:p>
+            <a:endParaRPr lang="es-CO"/>
+          </a:p>
+        </p:txBody>
       </p:sp>
       <p:sp>
         <p:nvSpPr>
@@ -7814,7 +7867,7 @@
           <a:bodyPr wrap="square" lIns="0" tIns="0" rIns="0" bIns="0" rtlCol="0" anchor="t"/>
           <a:lstStyle/>
           <a:p>
-            <a:pPr algn="ctr" indent="0" marL="0">
+            <a:pPr marL="0" indent="0" algn="ctr">
               <a:buNone/>
             </a:pPr>
             <a:r>
@@ -7850,7 +7903,7 @@
           <a:bodyPr wrap="square" lIns="0" tIns="0" rIns="0" bIns="0" rtlCol="0" anchor="t"/>
           <a:lstStyle/>
           <a:p>
-            <a:pPr algn="ctr" indent="0" marL="0">
+            <a:pPr marL="0" indent="0" algn="ctr">
               <a:buNone/>
             </a:pPr>
             <a:r>
@@ -7886,7 +7939,7 @@
           <a:bodyPr wrap="square" lIns="0" tIns="0" rIns="0" bIns="0" rtlCol="0" anchor="t"/>
           <a:lstStyle/>
           <a:p>
-            <a:pPr indent="0" marL="0">
+            <a:pPr marL="0" indent="0">
               <a:buNone/>
             </a:pPr>
             <a:r>
@@ -7922,7 +7975,7 @@
           <a:bodyPr wrap="square" lIns="0" tIns="0" rIns="0" bIns="0" rtlCol="0" anchor="ctr"/>
           <a:lstStyle/>
           <a:p>
-            <a:pPr indent="0" marL="0">
+            <a:pPr marL="0" indent="0">
               <a:buNone/>
             </a:pPr>
             <a:r>
@@ -7961,7 +8014,7 @@
           <a:bodyPr wrap="square" lIns="0" tIns="0" rIns="0" bIns="0" rtlCol="0" anchor="ctr"/>
           <a:lstStyle/>
           <a:p>
-            <a:pPr indent="0" marL="0">
+            <a:pPr marL="0" indent="0">
               <a:buNone/>
             </a:pPr>
             <a:r>
@@ -7997,7 +8050,7 @@
           <a:bodyPr wrap="square" lIns="0" tIns="0" rIns="0" bIns="0" rtlCol="0" anchor="ctr"/>
           <a:lstStyle/>
           <a:p>
-            <a:pPr indent="0" marL="0">
+            <a:pPr marL="0" indent="0">
               <a:buNone/>
             </a:pPr>
             <a:r>
@@ -8036,7 +8089,7 @@
           <a:bodyPr wrap="square" lIns="0" tIns="0" rIns="0" bIns="0" rtlCol="0" anchor="ctr"/>
           <a:lstStyle/>
           <a:p>
-            <a:pPr indent="0" marL="0">
+            <a:pPr marL="0" indent="0">
               <a:buNone/>
             </a:pPr>
             <a:r>
@@ -8072,7 +8125,7 @@
           <a:bodyPr wrap="square" lIns="0" tIns="0" rIns="0" bIns="0" rtlCol="0" anchor="ctr"/>
           <a:lstStyle/>
           <a:p>
-            <a:pPr indent="0" marL="0">
+            <a:pPr marL="0" indent="0">
               <a:buNone/>
             </a:pPr>
             <a:r>
@@ -8111,7 +8164,7 @@
           <a:bodyPr wrap="square" lIns="0" tIns="0" rIns="0" bIns="0" rtlCol="0" anchor="ctr"/>
           <a:lstStyle/>
           <a:p>
-            <a:pPr indent="0" marL="0">
+            <a:pPr marL="0" indent="0">
               <a:buNone/>
             </a:pPr>
             <a:r>
@@ -8128,7 +8181,7 @@
       </p:sp>
       <p:sp>
         <p:nvSpPr>
-          <p:cNvPr id="25" name="Slide Number Placeholder 0"/>
+          <p:cNvPr id="28" name="Slide Number Placeholder 0"/>
           <p:cNvSpPr>
             <a:spLocks noGrp="1"/>
           </p:cNvSpPr>
@@ -8146,7 +8199,7 @@
           </a:prstGeom>
           <a:extLst>
             <a:ext uri="{C572A759-6A51-4108-AA02-DFA0A04FC94B}">
-              <ma14:wrappingTextBoxFlag xmlns:ma14="http://schemas.microsoft.com/office/mac/drawingml/2011/main" val="0"/>
+              <ma14:wrappingTextBoxFlag xmlns:ma14="http://schemas.microsoft.com/office/mac/drawingml/2011/main" xmlns="" val="0"/>
             </a:ext>
           </a:extLst>
         </p:spPr>
@@ -8164,7 +8217,7 @@
           <a:p>
             <a:pPr algn="r"/>
             <a:fld id="{F7021451-1387-4CA6-816F-3879F97B5CBC}" type="slidenum">
-              <a:rPr b="0" lang="en-US"/>
+              <a:rPr lang="en-US" b="0"/>
               <a:t>3</a:t>
             </a:fld>
             <a:endParaRPr lang="en-US"/>
@@ -8199,9 +8252,11 @@
       <p:sp>
         <p:nvSpPr>
           <p:cNvPr id="2" name="Text 0"/>
-          <p:cNvSpPr/>
+          <p:cNvSpPr>
+            <a:spLocks noGrp="1"/>
+          </p:cNvSpPr>
           <p:nvPr>
-            <p:ph idx="100" type="title" hasCustomPrompt="1"/>
+            <p:ph type="title" idx="100" hasCustomPrompt="1"/>
           </p:nvPr>
         </p:nvSpPr>
         <p:spPr>
@@ -8219,7 +8274,7 @@
           <a:bodyPr wrap="square" lIns="0" tIns="0" rIns="0" bIns="0" rtlCol="0" anchor="ctr"/>
           <a:lstStyle/>
           <a:p>
-            <a:pPr indent="0" marL="0">
+            <a:pPr marL="0" indent="0">
               <a:buNone/>
             </a:pPr>
             <a:r>
@@ -8263,6 +8318,13 @@
             <a:prstDash val="solid"/>
           </a:ln>
         </p:spPr>
+        <p:txBody>
+          <a:bodyPr/>
+          <a:lstStyle/>
+          <a:p>
+            <a:endParaRPr lang="es-CO"/>
+          </a:p>
+        </p:txBody>
       </p:sp>
       <p:sp>
         <p:nvSpPr>
@@ -8288,6 +8350,13 @@
             <a:prstDash val="solid"/>
           </a:ln>
         </p:spPr>
+        <p:txBody>
+          <a:bodyPr/>
+          <a:lstStyle/>
+          <a:p>
+            <a:endParaRPr lang="es-CO"/>
+          </a:p>
+        </p:txBody>
       </p:sp>
       <p:sp>
         <p:nvSpPr>
@@ -8310,7 +8379,7 @@
           <a:bodyPr wrap="square" lIns="0" tIns="0" rIns="0" bIns="0" rtlCol="0" anchor="ctr"/>
           <a:lstStyle/>
           <a:p>
-            <a:pPr algn="ctr" indent="0" marL="0">
+            <a:pPr marL="0" indent="0" algn="ctr">
               <a:buNone/>
             </a:pPr>
             <a:r>
@@ -8346,7 +8415,7 @@
           <a:bodyPr wrap="square" lIns="0" tIns="0" rIns="0" bIns="0" rtlCol="0" anchor="ctr"/>
           <a:lstStyle/>
           <a:p>
-            <a:pPr indent="0" marL="0">
+            <a:pPr marL="0" indent="0">
               <a:buNone/>
             </a:pPr>
             <a:r>
@@ -8382,7 +8451,7 @@
           <a:bodyPr wrap="square" lIns="0" tIns="0" rIns="0" bIns="0" rtlCol="0" anchor="t"/>
           <a:lstStyle/>
           <a:p>
-            <a:pPr indent="0" marL="0">
+            <a:pPr marL="0" indent="0">
               <a:buNone/>
             </a:pPr>
             <a:r>
@@ -8418,7 +8487,7 @@
           <a:bodyPr wrap="square" lIns="0" tIns="0" rIns="0" bIns="0" rtlCol="0" anchor="t"/>
           <a:lstStyle/>
           <a:p>
-            <a:pPr indent="0" marL="0">
+            <a:pPr marL="0" indent="0">
               <a:buNone/>
             </a:pPr>
             <a:r>
@@ -8454,7 +8523,7 @@
           <a:bodyPr wrap="square" lIns="0" tIns="0" rIns="0" bIns="0" rtlCol="0" anchor="t"/>
           <a:lstStyle/>
           <a:p>
-            <a:pPr indent="0" marL="0">
+            <a:pPr marL="0" indent="0">
               <a:buNone/>
             </a:pPr>
             <a:r>
@@ -8495,6 +8564,13 @@
             <a:prstDash val="solid"/>
           </a:ln>
         </p:spPr>
+        <p:txBody>
+          <a:bodyPr/>
+          <a:lstStyle/>
+          <a:p>
+            <a:endParaRPr lang="es-CO"/>
+          </a:p>
+        </p:txBody>
       </p:sp>
       <p:sp>
         <p:nvSpPr>
@@ -8520,6 +8596,13 @@
             <a:prstDash val="solid"/>
           </a:ln>
         </p:spPr>
+        <p:txBody>
+          <a:bodyPr/>
+          <a:lstStyle/>
+          <a:p>
+            <a:endParaRPr lang="es-CO"/>
+          </a:p>
+        </p:txBody>
       </p:sp>
       <p:sp>
         <p:nvSpPr>
@@ -8542,7 +8625,7 @@
           <a:bodyPr wrap="square" lIns="0" tIns="0" rIns="0" bIns="0" rtlCol="0" anchor="ctr"/>
           <a:lstStyle/>
           <a:p>
-            <a:pPr algn="ctr" indent="0" marL="0">
+            <a:pPr marL="0" indent="0" algn="ctr">
               <a:buNone/>
             </a:pPr>
             <a:r>
@@ -8578,7 +8661,7 @@
           <a:bodyPr wrap="square" lIns="0" tIns="0" rIns="0" bIns="0" rtlCol="0" anchor="ctr"/>
           <a:lstStyle/>
           <a:p>
-            <a:pPr indent="0" marL="0">
+            <a:pPr marL="0" indent="0">
               <a:buNone/>
             </a:pPr>
             <a:r>
@@ -8614,7 +8697,7 @@
           <a:bodyPr wrap="square" lIns="0" tIns="0" rIns="0" bIns="0" rtlCol="0" anchor="t"/>
           <a:lstStyle/>
           <a:p>
-            <a:pPr indent="0" marL="0">
+            <a:pPr marL="0" indent="0">
               <a:buNone/>
             </a:pPr>
             <a:r>
@@ -8650,7 +8733,7 @@
           <a:bodyPr wrap="square" lIns="0" tIns="0" rIns="0" bIns="0" rtlCol="0" anchor="t"/>
           <a:lstStyle/>
           <a:p>
-            <a:pPr indent="0" marL="0">
+            <a:pPr marL="0" indent="0">
               <a:buNone/>
             </a:pPr>
             <a:r>
@@ -8686,7 +8769,7 @@
           <a:bodyPr wrap="square" lIns="0" tIns="0" rIns="0" bIns="0" rtlCol="0" anchor="t"/>
           <a:lstStyle/>
           <a:p>
-            <a:pPr indent="0" marL="0">
+            <a:pPr marL="0" indent="0">
               <a:buNone/>
             </a:pPr>
             <a:r>
@@ -8727,6 +8810,13 @@
             <a:prstDash val="solid"/>
           </a:ln>
         </p:spPr>
+        <p:txBody>
+          <a:bodyPr/>
+          <a:lstStyle/>
+          <a:p>
+            <a:endParaRPr lang="es-CO"/>
+          </a:p>
+        </p:txBody>
       </p:sp>
       <p:sp>
         <p:nvSpPr>
@@ -8752,6 +8842,13 @@
             <a:prstDash val="solid"/>
           </a:ln>
         </p:spPr>
+        <p:txBody>
+          <a:bodyPr/>
+          <a:lstStyle/>
+          <a:p>
+            <a:endParaRPr lang="es-CO"/>
+          </a:p>
+        </p:txBody>
       </p:sp>
       <p:sp>
         <p:nvSpPr>
@@ -8774,7 +8871,7 @@
           <a:bodyPr wrap="square" lIns="0" tIns="0" rIns="0" bIns="0" rtlCol="0" anchor="ctr"/>
           <a:lstStyle/>
           <a:p>
-            <a:pPr algn="ctr" indent="0" marL="0">
+            <a:pPr marL="0" indent="0" algn="ctr">
               <a:buNone/>
             </a:pPr>
             <a:r>
@@ -8810,7 +8907,7 @@
           <a:bodyPr wrap="square" lIns="0" tIns="0" rIns="0" bIns="0" rtlCol="0" anchor="ctr"/>
           <a:lstStyle/>
           <a:p>
-            <a:pPr indent="0" marL="0">
+            <a:pPr marL="0" indent="0">
               <a:buNone/>
             </a:pPr>
             <a:r>
@@ -8846,7 +8943,7 @@
           <a:bodyPr wrap="square" lIns="0" tIns="0" rIns="0" bIns="0" rtlCol="0" anchor="t"/>
           <a:lstStyle/>
           <a:p>
-            <a:pPr indent="0" marL="0">
+            <a:pPr marL="0" indent="0">
               <a:buNone/>
             </a:pPr>
             <a:r>
@@ -8882,7 +8979,7 @@
           <a:bodyPr wrap="square" lIns="0" tIns="0" rIns="0" bIns="0" rtlCol="0" anchor="t"/>
           <a:lstStyle/>
           <a:p>
-            <a:pPr indent="0" marL="0">
+            <a:pPr marL="0" indent="0">
               <a:buNone/>
             </a:pPr>
             <a:r>
@@ -8918,7 +9015,7 @@
           <a:bodyPr wrap="square" lIns="0" tIns="0" rIns="0" bIns="0" rtlCol="0" anchor="t"/>
           <a:lstStyle/>
           <a:p>
-            <a:pPr indent="0" marL="0">
+            <a:pPr marL="0" indent="0">
               <a:buNone/>
             </a:pPr>
             <a:r>
@@ -8953,7 +9050,7 @@
           </a:prstGeom>
           <a:extLst>
             <a:ext uri="{C572A759-6A51-4108-AA02-DFA0A04FC94B}">
-              <ma14:wrappingTextBoxFlag xmlns:ma14="http://schemas.microsoft.com/office/mac/drawingml/2011/main" val="0"/>
+              <ma14:wrappingTextBoxFlag xmlns:ma14="http://schemas.microsoft.com/office/mac/drawingml/2011/main" xmlns="" val="0"/>
             </a:ext>
           </a:extLst>
         </p:spPr>
@@ -8971,7 +9068,7 @@
           <a:p>
             <a:pPr algn="r"/>
             <a:fld id="{F7021451-1387-4CA6-816F-3879F97B5CBC}" type="slidenum">
-              <a:rPr b="0" lang="en-US"/>
+              <a:rPr lang="en-US" b="0"/>
               <a:t>4</a:t>
             </a:fld>
             <a:endParaRPr lang="en-US"/>
@@ -9006,9 +9103,11 @@
       <p:sp>
         <p:nvSpPr>
           <p:cNvPr id="2" name="Text 0"/>
-          <p:cNvSpPr/>
+          <p:cNvSpPr>
+            <a:spLocks noGrp="1"/>
+          </p:cNvSpPr>
           <p:nvPr>
-            <p:ph idx="100" type="title" hasCustomPrompt="1"/>
+            <p:ph type="title" idx="100" hasCustomPrompt="1"/>
           </p:nvPr>
         </p:nvSpPr>
         <p:spPr>
@@ -9026,7 +9125,7 @@
           <a:bodyPr wrap="square" lIns="0" tIns="0" rIns="0" bIns="0" rtlCol="0" anchor="ctr"/>
           <a:lstStyle/>
           <a:p>
-            <a:pPr indent="0" marL="0">
+            <a:pPr marL="0" indent="0">
               <a:buNone/>
             </a:pPr>
             <a:r>
@@ -9046,7 +9145,7 @@
       </p:sp>
       <p:graphicFrame>
         <p:nvGraphicFramePr>
-          <p:cNvPr id="3" name="Chart 0" descr=""/>
+          <p:cNvPr id="3" name="Chart 0"/>
           <p:cNvGraphicFramePr/>
           <p:nvPr/>
         </p:nvGraphicFramePr>
@@ -9054,9 +9153,9 @@
           <a:off x="365760" y="1097280"/>
           <a:ext cx="4937760" cy="3474720"/>
         </p:xfrm>
-        <a:graphic xmlns:a="http://schemas.openxmlformats.org/drawingml/2006/main">
+        <a:graphic>
           <a:graphicData uri="http://schemas.openxmlformats.org/drawingml/2006/chart">
-            <c:chart xmlns:c="http://schemas.openxmlformats.org/drawingml/2006/chart" r:id="rId1"/>
+            <c:chart xmlns:c="http://schemas.openxmlformats.org/drawingml/2006/chart" xmlns:r="http://schemas.openxmlformats.org/officeDocument/2006/relationships" r:id="rId3"/>
           </a:graphicData>
         </a:graphic>
       </p:graphicFrame>
@@ -9086,6 +9185,13 @@
             <a:prstDash val="solid"/>
           </a:ln>
         </p:spPr>
+        <p:txBody>
+          <a:bodyPr/>
+          <a:lstStyle/>
+          <a:p>
+            <a:endParaRPr lang="es-CO"/>
+          </a:p>
+        </p:txBody>
       </p:sp>
       <p:sp>
         <p:nvSpPr>
@@ -9108,7 +9214,7 @@
           <a:bodyPr wrap="square" lIns="0" tIns="0" rIns="0" bIns="0" rtlCol="0" anchor="t"/>
           <a:lstStyle/>
           <a:p>
-            <a:pPr indent="0" marL="0">
+            <a:pPr marL="0" indent="0">
               <a:buNone/>
             </a:pPr>
             <a:r>
@@ -9237,7 +9343,7 @@
           </a:prstGeom>
           <a:extLst>
             <a:ext uri="{C572A759-6A51-4108-AA02-DFA0A04FC94B}">
-              <ma14:wrappingTextBoxFlag xmlns:ma14="http://schemas.microsoft.com/office/mac/drawingml/2011/main" val="0"/>
+              <ma14:wrappingTextBoxFlag xmlns:ma14="http://schemas.microsoft.com/office/mac/drawingml/2011/main" xmlns="" val="0"/>
             </a:ext>
           </a:extLst>
         </p:spPr>
@@ -9255,7 +9361,7 @@
           <a:p>
             <a:pPr algn="r"/>
             <a:fld id="{F7021451-1387-4CA6-816F-3879F97B5CBC}" type="slidenum">
-              <a:rPr b="0" lang="en-US"/>
+              <a:rPr lang="en-US" b="0"/>
               <a:t>5</a:t>
             </a:fld>
             <a:endParaRPr lang="en-US"/>
@@ -9290,9 +9396,11 @@
       <p:sp>
         <p:nvSpPr>
           <p:cNvPr id="2" name="Text 0"/>
-          <p:cNvSpPr/>
+          <p:cNvSpPr>
+            <a:spLocks noGrp="1"/>
+          </p:cNvSpPr>
           <p:nvPr>
-            <p:ph idx="100" type="title" hasCustomPrompt="1"/>
+            <p:ph type="title" idx="100" hasCustomPrompt="1"/>
           </p:nvPr>
         </p:nvSpPr>
         <p:spPr>
@@ -9310,7 +9418,7 @@
           <a:bodyPr wrap="square" lIns="0" tIns="0" rIns="0" bIns="0" rtlCol="0" anchor="ctr"/>
           <a:lstStyle/>
           <a:p>
-            <a:pPr indent="0" marL="0">
+            <a:pPr marL="0" indent="0">
               <a:buNone/>
             </a:pPr>
             <a:r>
@@ -9354,6 +9462,13 @@
             <a:prstDash val="solid"/>
           </a:ln>
         </p:spPr>
+        <p:txBody>
+          <a:bodyPr/>
+          <a:lstStyle/>
+          <a:p>
+            <a:endParaRPr lang="es-CO"/>
+          </a:p>
+        </p:txBody>
       </p:sp>
       <p:sp>
         <p:nvSpPr>
@@ -9376,7 +9491,7 @@
           <a:bodyPr wrap="square" lIns="0" tIns="0" rIns="0" bIns="0" rtlCol="0" anchor="ctr"/>
           <a:lstStyle/>
           <a:p>
-            <a:pPr algn="ctr" indent="0" marL="0">
+            <a:pPr marL="0" indent="0" algn="ctr">
               <a:buNone/>
             </a:pPr>
             <a:r>
@@ -9390,7 +9505,7 @@
             <a:endParaRPr lang="en-US" sz="1200" dirty="0"/>
           </a:p>
           <a:p>
-            <a:pPr algn="ctr" indent="0" marL="0">
+            <a:pPr marL="0" indent="0" algn="ctr">
               <a:buNone/>
             </a:pPr>
             <a:r>
@@ -9431,6 +9546,13 @@
             <a:prstDash val="solid"/>
           </a:ln>
         </p:spPr>
+        <p:txBody>
+          <a:bodyPr/>
+          <a:lstStyle/>
+          <a:p>
+            <a:endParaRPr lang="es-CO"/>
+          </a:p>
+        </p:txBody>
       </p:sp>
       <p:sp>
         <p:nvSpPr>
@@ -9453,7 +9575,7 @@
           <a:bodyPr wrap="square" lIns="0" tIns="0" rIns="0" bIns="0" rtlCol="0" anchor="ctr"/>
           <a:lstStyle/>
           <a:p>
-            <a:pPr algn="ctr" indent="0" marL="0">
+            <a:pPr marL="0" indent="0" algn="ctr">
               <a:buNone/>
             </a:pPr>
             <a:r>
@@ -9467,7 +9589,7 @@
             <a:endParaRPr lang="en-US" sz="1200" dirty="0"/>
           </a:p>
           <a:p>
-            <a:pPr algn="ctr" indent="0" marL="0">
+            <a:pPr marL="0" indent="0" algn="ctr">
               <a:buNone/>
             </a:pPr>
             <a:r>
@@ -9508,6 +9630,13 @@
             <a:prstDash val="solid"/>
           </a:ln>
         </p:spPr>
+        <p:txBody>
+          <a:bodyPr/>
+          <a:lstStyle/>
+          <a:p>
+            <a:endParaRPr lang="es-CO"/>
+          </a:p>
+        </p:txBody>
       </p:sp>
       <p:sp>
         <p:nvSpPr>
@@ -9530,7 +9659,7 @@
           <a:bodyPr wrap="square" lIns="0" tIns="0" rIns="0" bIns="0" rtlCol="0" anchor="ctr"/>
           <a:lstStyle/>
           <a:p>
-            <a:pPr algn="ctr" indent="0" marL="0">
+            <a:pPr marL="0" indent="0" algn="ctr">
               <a:buNone/>
             </a:pPr>
             <a:r>
@@ -9544,7 +9673,7 @@
             <a:endParaRPr lang="en-US" sz="1200" dirty="0"/>
           </a:p>
           <a:p>
-            <a:pPr algn="ctr" indent="0" marL="0">
+            <a:pPr marL="0" indent="0" algn="ctr">
               <a:buNone/>
             </a:pPr>
             <a:r>
@@ -9585,6 +9714,13 @@
             <a:prstDash val="solid"/>
           </a:ln>
         </p:spPr>
+        <p:txBody>
+          <a:bodyPr/>
+          <a:lstStyle/>
+          <a:p>
+            <a:endParaRPr lang="es-CO"/>
+          </a:p>
+        </p:txBody>
       </p:sp>
       <p:sp>
         <p:nvSpPr>
@@ -9607,7 +9743,7 @@
           <a:bodyPr wrap="square" lIns="0" tIns="0" rIns="0" bIns="0" rtlCol="0" anchor="ctr"/>
           <a:lstStyle/>
           <a:p>
-            <a:pPr algn="ctr" indent="0" marL="0">
+            <a:pPr marL="0" indent="0" algn="ctr">
               <a:buNone/>
             </a:pPr>
             <a:r>
@@ -9621,7 +9757,7 @@
             <a:endParaRPr lang="en-US" sz="1200" dirty="0"/>
           </a:p>
           <a:p>
-            <a:pPr algn="ctr" indent="0" marL="0">
+            <a:pPr marL="0" indent="0" algn="ctr">
               <a:buNone/>
             </a:pPr>
             <a:r>
@@ -9662,6 +9798,13 @@
             <a:prstDash val="solid"/>
           </a:ln>
         </p:spPr>
+        <p:txBody>
+          <a:bodyPr/>
+          <a:lstStyle/>
+          <a:p>
+            <a:endParaRPr lang="es-CO"/>
+          </a:p>
+        </p:txBody>
       </p:sp>
       <p:sp>
         <p:nvSpPr>
@@ -9684,7 +9827,7 @@
           <a:bodyPr wrap="square" lIns="0" tIns="0" rIns="0" bIns="0" rtlCol="0" anchor="ctr"/>
           <a:lstStyle/>
           <a:p>
-            <a:pPr algn="ctr" indent="0" marL="0">
+            <a:pPr marL="0" indent="0" algn="ctr">
               <a:buNone/>
             </a:pPr>
             <a:r>
@@ -9698,7 +9841,7 @@
             <a:endParaRPr lang="en-US" sz="1200" dirty="0"/>
           </a:p>
           <a:p>
-            <a:pPr algn="ctr" indent="0" marL="0">
+            <a:pPr marL="0" indent="0" algn="ctr">
               <a:buNone/>
             </a:pPr>
             <a:r>
@@ -9736,6 +9879,13 @@
             <a:tailEnd type="triangle"/>
           </a:ln>
         </p:spPr>
+        <p:txBody>
+          <a:bodyPr/>
+          <a:lstStyle/>
+          <a:p>
+            <a:endParaRPr lang="es-CO"/>
+          </a:p>
+        </p:txBody>
       </p:sp>
       <p:sp>
         <p:nvSpPr>
@@ -9760,6 +9910,13 @@
             <a:tailEnd type="triangle"/>
           </a:ln>
         </p:spPr>
+        <p:txBody>
+          <a:bodyPr/>
+          <a:lstStyle/>
+          <a:p>
+            <a:endParaRPr lang="es-CO"/>
+          </a:p>
+        </p:txBody>
       </p:sp>
       <p:sp>
         <p:nvSpPr>
@@ -9784,6 +9941,13 @@
             <a:tailEnd type="triangle"/>
           </a:ln>
         </p:spPr>
+        <p:txBody>
+          <a:bodyPr/>
+          <a:lstStyle/>
+          <a:p>
+            <a:endParaRPr lang="es-CO"/>
+          </a:p>
+        </p:txBody>
       </p:sp>
       <p:sp>
         <p:nvSpPr>
@@ -9808,6 +9972,13 @@
             <a:tailEnd type="triangle"/>
           </a:ln>
         </p:spPr>
+        <p:txBody>
+          <a:bodyPr/>
+          <a:lstStyle/>
+          <a:p>
+            <a:endParaRPr lang="es-CO"/>
+          </a:p>
+        </p:txBody>
       </p:sp>
       <p:sp>
         <p:nvSpPr>
@@ -9832,6 +10003,13 @@
             <a:tailEnd type="triangle"/>
           </a:ln>
         </p:spPr>
+        <p:txBody>
+          <a:bodyPr/>
+          <a:lstStyle/>
+          <a:p>
+            <a:endParaRPr lang="es-CO"/>
+          </a:p>
+        </p:txBody>
       </p:sp>
       <p:sp>
         <p:nvSpPr>
@@ -9854,7 +10032,7 @@
           <a:bodyPr wrap="square" lIns="0" tIns="0" rIns="0" bIns="0" rtlCol="0" anchor="t"/>
           <a:lstStyle/>
           <a:p>
-            <a:pPr indent="0" marL="0">
+            <a:pPr marL="0" indent="0">
               <a:buNone/>
             </a:pPr>
             <a:r>
@@ -9898,6 +10076,13 @@
             <a:prstDash val="solid"/>
           </a:ln>
         </p:spPr>
+        <p:txBody>
+          <a:bodyPr/>
+          <a:lstStyle/>
+          <a:p>
+            <a:endParaRPr lang="es-CO"/>
+          </a:p>
+        </p:txBody>
       </p:sp>
       <p:sp>
         <p:nvSpPr>
@@ -9920,7 +10105,7 @@
           <a:bodyPr wrap="square" lIns="0" tIns="0" rIns="0" bIns="0" rtlCol="0" anchor="ctr"/>
           <a:lstStyle/>
           <a:p>
-            <a:pPr algn="ctr" indent="0" marL="0">
+            <a:pPr marL="0" indent="0" algn="ctr">
               <a:buNone/>
             </a:pPr>
             <a:r>
@@ -9961,6 +10146,13 @@
             <a:prstDash val="solid"/>
           </a:ln>
         </p:spPr>
+        <p:txBody>
+          <a:bodyPr/>
+          <a:lstStyle/>
+          <a:p>
+            <a:endParaRPr lang="es-CO"/>
+          </a:p>
+        </p:txBody>
       </p:sp>
       <p:sp>
         <p:nvSpPr>
@@ -9983,7 +10175,7 @@
           <a:bodyPr wrap="square" lIns="0" tIns="0" rIns="0" bIns="0" rtlCol="0" anchor="ctr"/>
           <a:lstStyle/>
           <a:p>
-            <a:pPr algn="ctr" indent="0" marL="0">
+            <a:pPr marL="0" indent="0" algn="ctr">
               <a:buNone/>
             </a:pPr>
             <a:r>
@@ -10024,6 +10216,13 @@
             <a:prstDash val="solid"/>
           </a:ln>
         </p:spPr>
+        <p:txBody>
+          <a:bodyPr/>
+          <a:lstStyle/>
+          <a:p>
+            <a:endParaRPr lang="es-CO"/>
+          </a:p>
+        </p:txBody>
       </p:sp>
       <p:sp>
         <p:nvSpPr>
@@ -10046,7 +10245,7 @@
           <a:bodyPr wrap="square" lIns="0" tIns="0" rIns="0" bIns="0" rtlCol="0" anchor="ctr"/>
           <a:lstStyle/>
           <a:p>
-            <a:pPr algn="ctr" indent="0" marL="0">
+            <a:pPr marL="0" indent="0" algn="ctr">
               <a:buNone/>
             </a:pPr>
             <a:r>
@@ -10087,6 +10286,13 @@
             <a:prstDash val="solid"/>
           </a:ln>
         </p:spPr>
+        <p:txBody>
+          <a:bodyPr/>
+          <a:lstStyle/>
+          <a:p>
+            <a:endParaRPr lang="es-CO"/>
+          </a:p>
+        </p:txBody>
       </p:sp>
       <p:sp>
         <p:nvSpPr>
@@ -10109,7 +10315,7 @@
           <a:bodyPr wrap="square" lIns="0" tIns="0" rIns="0" bIns="0" rtlCol="0" anchor="ctr"/>
           <a:lstStyle/>
           <a:p>
-            <a:pPr algn="ctr" indent="0" marL="0">
+            <a:pPr marL="0" indent="0" algn="ctr">
               <a:buNone/>
             </a:pPr>
             <a:r>
@@ -10126,7 +10332,7 @@
       </p:sp>
       <p:sp>
         <p:nvSpPr>
-          <p:cNvPr id="25" name="Slide Number Placeholder 0"/>
+          <p:cNvPr id="27" name="Slide Number Placeholder 0"/>
           <p:cNvSpPr>
             <a:spLocks noGrp="1"/>
           </p:cNvSpPr>
@@ -10144,7 +10350,7 @@
           </a:prstGeom>
           <a:extLst>
             <a:ext uri="{C572A759-6A51-4108-AA02-DFA0A04FC94B}">
-              <ma14:wrappingTextBoxFlag xmlns:ma14="http://schemas.microsoft.com/office/mac/drawingml/2011/main" val="0"/>
+              <ma14:wrappingTextBoxFlag xmlns:ma14="http://schemas.microsoft.com/office/mac/drawingml/2011/main" xmlns="" val="0"/>
             </a:ext>
           </a:extLst>
         </p:spPr>
@@ -10162,7 +10368,7 @@
           <a:p>
             <a:pPr algn="r"/>
             <a:fld id="{F7021451-1387-4CA6-816F-3879F97B5CBC}" type="slidenum">
-              <a:rPr b="0" lang="en-US"/>
+              <a:rPr lang="en-US" b="0"/>
               <a:t>6</a:t>
             </a:fld>
             <a:endParaRPr lang="en-US"/>
@@ -10197,9 +10403,11 @@
       <p:sp>
         <p:nvSpPr>
           <p:cNvPr id="2" name="Text 0"/>
-          <p:cNvSpPr/>
+          <p:cNvSpPr>
+            <a:spLocks noGrp="1"/>
+          </p:cNvSpPr>
           <p:nvPr>
-            <p:ph idx="100" type="title" hasCustomPrompt="1"/>
+            <p:ph type="title" idx="100" hasCustomPrompt="1"/>
           </p:nvPr>
         </p:nvSpPr>
         <p:spPr>
@@ -10217,7 +10425,7 @@
           <a:bodyPr wrap="square" lIns="0" tIns="0" rIns="0" bIns="0" rtlCol="0" anchor="ctr"/>
           <a:lstStyle/>
           <a:p>
-            <a:pPr indent="0" marL="0">
+            <a:pPr marL="0" indent="0">
               <a:buNone/>
             </a:pPr>
             <a:r>
@@ -10237,7 +10445,7 @@
       </p:sp>
       <p:graphicFrame>
         <p:nvGraphicFramePr>
-          <p:cNvPr id="3" name="Chart 0" descr=""/>
+          <p:cNvPr id="3" name="Chart 0"/>
           <p:cNvGraphicFramePr/>
           <p:nvPr/>
         </p:nvGraphicFramePr>
@@ -10245,9 +10453,9 @@
           <a:off x="365760" y="1097280"/>
           <a:ext cx="4754880" cy="3474720"/>
         </p:xfrm>
-        <a:graphic xmlns:a="http://schemas.openxmlformats.org/drawingml/2006/main">
+        <a:graphic>
           <a:graphicData uri="http://schemas.openxmlformats.org/drawingml/2006/chart">
-            <c:chart xmlns:c="http://schemas.openxmlformats.org/drawingml/2006/chart" r:id="rId1"/>
+            <c:chart xmlns:c="http://schemas.openxmlformats.org/drawingml/2006/chart" xmlns:r="http://schemas.openxmlformats.org/officeDocument/2006/relationships" r:id="rId3"/>
           </a:graphicData>
         </a:graphic>
       </p:graphicFrame>
@@ -10277,6 +10485,13 @@
             <a:prstDash val="solid"/>
           </a:ln>
         </p:spPr>
+        <p:txBody>
+          <a:bodyPr/>
+          <a:lstStyle/>
+          <a:p>
+            <a:endParaRPr lang="es-CO"/>
+          </a:p>
+        </p:txBody>
       </p:sp>
       <p:sp>
         <p:nvSpPr>
@@ -10299,7 +10514,7 @@
           <a:bodyPr wrap="square" lIns="0" tIns="0" rIns="0" bIns="0" rtlCol="0" anchor="t"/>
           <a:lstStyle/>
           <a:p>
-            <a:pPr indent="0" marL="0">
+            <a:pPr marL="0" indent="0">
               <a:buNone/>
             </a:pPr>
             <a:r>
@@ -10429,7 +10644,7 @@
           <a:bodyPr wrap="square" lIns="0" tIns="0" rIns="0" bIns="0" rtlCol="0" anchor="t"/>
           <a:lstStyle/>
           <a:p>
-            <a:pPr indent="0" marL="0">
+            <a:pPr marL="0" indent="0">
               <a:buNone/>
             </a:pPr>
             <a:r>
@@ -10464,7 +10679,7 @@
           </a:prstGeom>
           <a:extLst>
             <a:ext uri="{C572A759-6A51-4108-AA02-DFA0A04FC94B}">
-              <ma14:wrappingTextBoxFlag xmlns:ma14="http://schemas.microsoft.com/office/mac/drawingml/2011/main" val="0"/>
+              <ma14:wrappingTextBoxFlag xmlns:ma14="http://schemas.microsoft.com/office/mac/drawingml/2011/main" xmlns="" val="0"/>
             </a:ext>
           </a:extLst>
         </p:spPr>
@@ -10482,7 +10697,7 @@
           <a:p>
             <a:pPr algn="r"/>
             <a:fld id="{F7021451-1387-4CA6-816F-3879F97B5CBC}" type="slidenum">
-              <a:rPr b="0" lang="en-US"/>
+              <a:rPr lang="en-US" b="0"/>
               <a:t>7</a:t>
             </a:fld>
             <a:endParaRPr lang="en-US"/>
@@ -10517,9 +10732,11 @@
       <p:sp>
         <p:nvSpPr>
           <p:cNvPr id="2" name="Text 0"/>
-          <p:cNvSpPr/>
+          <p:cNvSpPr>
+            <a:spLocks noGrp="1"/>
+          </p:cNvSpPr>
           <p:nvPr>
-            <p:ph idx="100" type="title" hasCustomPrompt="1"/>
+            <p:ph type="title" idx="100" hasCustomPrompt="1"/>
           </p:nvPr>
         </p:nvSpPr>
         <p:spPr>
@@ -10537,7 +10754,7 @@
           <a:bodyPr wrap="square" lIns="0" tIns="0" rIns="0" bIns="0" rtlCol="0" anchor="ctr"/>
           <a:lstStyle/>
           <a:p>
-            <a:pPr indent="0" marL="0">
+            <a:pPr marL="0" indent="0">
               <a:buNone/>
             </a:pPr>
             <a:r>
@@ -10571,17 +10788,41 @@
         </p:nvGraphicFramePr>
         <p:xfrm>
           <a:off x="457200" y="1188720"/>
-          <a:ext cx="8229600" cy="914400"/>
+          <a:ext cx="8229600" cy="2194560"/>
         </p:xfrm>
         <a:graphic>
           <a:graphicData uri="http://schemas.openxmlformats.org/drawingml/2006/table">
             <a:tbl>
               <a:tblPr/>
               <a:tblGrid>
-                <a:gridCol w="3017520"/>
-                <a:gridCol w="1737360"/>
-                <a:gridCol w="1554480"/>
-                <a:gridCol w="1920240"/>
+                <a:gridCol w="3017520">
+                  <a:extLst>
+                    <a:ext uri="{9D8B030D-6E8A-4147-A177-3AD203B41FA5}">
+                      <a16:colId xmlns:a16="http://schemas.microsoft.com/office/drawing/2014/main" val="20000"/>
+                    </a:ext>
+                  </a:extLst>
+                </a:gridCol>
+                <a:gridCol w="1737360">
+                  <a:extLst>
+                    <a:ext uri="{9D8B030D-6E8A-4147-A177-3AD203B41FA5}">
+                      <a16:colId xmlns:a16="http://schemas.microsoft.com/office/drawing/2014/main" val="20001"/>
+                    </a:ext>
+                  </a:extLst>
+                </a:gridCol>
+                <a:gridCol w="1554480">
+                  <a:extLst>
+                    <a:ext uri="{9D8B030D-6E8A-4147-A177-3AD203B41FA5}">
+                      <a16:colId xmlns:a16="http://schemas.microsoft.com/office/drawing/2014/main" val="20002"/>
+                    </a:ext>
+                  </a:extLst>
+                </a:gridCol>
+                <a:gridCol w="1920240">
+                  <a:extLst>
+                    <a:ext uri="{9D8B030D-6E8A-4147-A177-3AD203B41FA5}">
+                      <a16:colId xmlns:a16="http://schemas.microsoft.com/office/drawing/2014/main" val="20003"/>
+                    </a:ext>
+                  </a:extLst>
+                </a:gridCol>
               </a:tblGrid>
               <a:tr h="438912">
                 <a:tc>
@@ -10589,7 +10830,7 @@
                     <a:bodyPr/>
                     <a:lstStyle/>
                     <a:p>
-                      <a:pPr indent="0" marL="0">
+                      <a:pPr marL="0" indent="0">
                         <a:buNone/>
                       </a:pPr>
                       <a:r>
@@ -10603,7 +10844,7 @@
                       <a:endParaRPr lang="en-US" sz="1200" dirty="0"/>
                     </a:p>
                   </a:txBody>
-                  <a:tcPr marL="91440" marR="91440" marT="45720" marB="45720" anchor="ctr">
+                  <a:tcPr anchor="ctr">
                     <a:lnL w="6350" cap="flat" cmpd="sng" algn="ctr">
                       <a:solidFill>
                         <a:srgbClr val="DCE6E4"/>
@@ -10650,7 +10891,7 @@
                     <a:bodyPr/>
                     <a:lstStyle/>
                     <a:p>
-                      <a:pPr indent="0" marL="0">
+                      <a:pPr marL="0" indent="0">
                         <a:buNone/>
                       </a:pPr>
                       <a:r>
@@ -10664,7 +10905,7 @@
                       <a:endParaRPr lang="en-US" sz="1200" dirty="0"/>
                     </a:p>
                   </a:txBody>
-                  <a:tcPr marL="91440" marR="91440" marT="45720" marB="45720" anchor="ctr">
+                  <a:tcPr anchor="ctr">
                     <a:lnL w="6350" cap="flat" cmpd="sng" algn="ctr">
                       <a:solidFill>
                         <a:srgbClr val="DCE6E4"/>
@@ -10711,7 +10952,7 @@
                     <a:bodyPr/>
                     <a:lstStyle/>
                     <a:p>
-                      <a:pPr indent="0" marL="0">
+                      <a:pPr marL="0" indent="0">
                         <a:buNone/>
                       </a:pPr>
                       <a:r>
@@ -10725,7 +10966,7 @@
                       <a:endParaRPr lang="en-US" sz="1200" dirty="0"/>
                     </a:p>
                   </a:txBody>
-                  <a:tcPr marL="91440" marR="91440" marT="45720" marB="45720" anchor="ctr">
+                  <a:tcPr anchor="ctr">
                     <a:lnL w="6350" cap="flat" cmpd="sng" algn="ctr">
                       <a:solidFill>
                         <a:srgbClr val="DCE6E4"/>
@@ -10772,7 +11013,7 @@
                     <a:bodyPr/>
                     <a:lstStyle/>
                     <a:p>
-                      <a:pPr indent="0" marL="0">
+                      <a:pPr marL="0" indent="0">
                         <a:buNone/>
                       </a:pPr>
                       <a:r>
@@ -10786,7 +11027,7 @@
                       <a:endParaRPr lang="en-US" sz="1200" dirty="0"/>
                     </a:p>
                   </a:txBody>
-                  <a:tcPr marL="91440" marR="91440" marT="45720" marB="45720" anchor="ctr">
+                  <a:tcPr anchor="ctr">
                     <a:lnL w="6350" cap="flat" cmpd="sng" algn="ctr">
                       <a:solidFill>
                         <a:srgbClr val="DCE6E4"/>
@@ -10828,6 +11069,11 @@
                     </a:solidFill>
                   </a:tcPr>
                 </a:tc>
+                <a:extLst>
+                  <a:ext uri="{0D108BD9-81ED-4DB2-BD59-A6C34878D82A}">
+                    <a16:rowId xmlns:a16="http://schemas.microsoft.com/office/drawing/2014/main" val="10000"/>
+                  </a:ext>
+                </a:extLst>
               </a:tr>
               <a:tr h="438912">
                 <a:tc>
@@ -10835,7 +11081,7 @@
                     <a:bodyPr/>
                     <a:lstStyle/>
                     <a:p>
-                      <a:pPr indent="0" marL="0">
+                      <a:pPr marL="0" indent="0">
                         <a:buNone/>
                       </a:pPr>
                       <a:r>
@@ -10849,7 +11095,7 @@
                       <a:endParaRPr lang="en-US" sz="1200" dirty="0"/>
                     </a:p>
                   </a:txBody>
-                  <a:tcPr marL="91440" marR="91440" marT="45720" marB="45720" anchor="ctr">
+                  <a:tcPr anchor="ctr">
                     <a:lnL w="6350" cap="flat" cmpd="sng" algn="ctr">
                       <a:solidFill>
                         <a:srgbClr val="DCE6E4"/>
@@ -10896,7 +11142,7 @@
                     <a:bodyPr/>
                     <a:lstStyle/>
                     <a:p>
-                      <a:pPr indent="0" marL="0">
+                      <a:pPr marL="0" indent="0">
                         <a:buNone/>
                       </a:pPr>
                       <a:r>
@@ -10910,7 +11156,7 @@
                       <a:endParaRPr lang="en-US" sz="1200" dirty="0"/>
                     </a:p>
                   </a:txBody>
-                  <a:tcPr marL="91440" marR="91440" marT="45720" marB="45720" anchor="ctr">
+                  <a:tcPr anchor="ctr">
                     <a:lnL w="6350" cap="flat" cmpd="sng" algn="ctr">
                       <a:solidFill>
                         <a:srgbClr val="DCE6E4"/>
@@ -10957,7 +11203,7 @@
                     <a:bodyPr/>
                     <a:lstStyle/>
                     <a:p>
-                      <a:pPr indent="0" marL="0">
+                      <a:pPr marL="0" indent="0">
                         <a:buNone/>
                       </a:pPr>
                       <a:r>
@@ -10971,7 +11217,7 @@
                       <a:endParaRPr lang="en-US" sz="1200" dirty="0"/>
                     </a:p>
                   </a:txBody>
-                  <a:tcPr marL="91440" marR="91440" marT="45720" marB="45720" anchor="ctr">
+                  <a:tcPr anchor="ctr">
                     <a:lnL w="6350" cap="flat" cmpd="sng" algn="ctr">
                       <a:solidFill>
                         <a:srgbClr val="DCE6E4"/>
@@ -11018,7 +11264,7 @@
                     <a:bodyPr/>
                     <a:lstStyle/>
                     <a:p>
-                      <a:pPr indent="0" marL="0">
+                      <a:pPr marL="0" indent="0">
                         <a:buNone/>
                       </a:pPr>
                       <a:r>
@@ -11032,7 +11278,7 @@
                       <a:endParaRPr lang="en-US" sz="1200" dirty="0"/>
                     </a:p>
                   </a:txBody>
-                  <a:tcPr marL="91440" marR="91440" marT="45720" marB="45720" anchor="ctr">
+                  <a:tcPr anchor="ctr">
                     <a:lnL w="6350" cap="flat" cmpd="sng" algn="ctr">
                       <a:solidFill>
                         <a:srgbClr val="DCE6E4"/>
@@ -11074,6 +11320,11 @@
                     </a:solidFill>
                   </a:tcPr>
                 </a:tc>
+                <a:extLst>
+                  <a:ext uri="{0D108BD9-81ED-4DB2-BD59-A6C34878D82A}">
+                    <a16:rowId xmlns:a16="http://schemas.microsoft.com/office/drawing/2014/main" val="10001"/>
+                  </a:ext>
+                </a:extLst>
               </a:tr>
               <a:tr h="438912">
                 <a:tc>
@@ -11081,7 +11332,7 @@
                     <a:bodyPr/>
                     <a:lstStyle/>
                     <a:p>
-                      <a:pPr indent="0" marL="0">
+                      <a:pPr marL="0" indent="0">
                         <a:buNone/>
                       </a:pPr>
                       <a:r>
@@ -11095,7 +11346,7 @@
                       <a:endParaRPr lang="en-US" sz="1200" dirty="0"/>
                     </a:p>
                   </a:txBody>
-                  <a:tcPr marL="91440" marR="91440" marT="45720" marB="45720" anchor="ctr">
+                  <a:tcPr anchor="ctr">
                     <a:lnL w="6350" cap="flat" cmpd="sng" algn="ctr">
                       <a:solidFill>
                         <a:srgbClr val="DCE6E4"/>
@@ -11142,7 +11393,7 @@
                     <a:bodyPr/>
                     <a:lstStyle/>
                     <a:p>
-                      <a:pPr indent="0" marL="0">
+                      <a:pPr marL="0" indent="0">
                         <a:buNone/>
                       </a:pPr>
                       <a:r>
@@ -11156,7 +11407,7 @@
                       <a:endParaRPr lang="en-US" sz="1200" dirty="0"/>
                     </a:p>
                   </a:txBody>
-                  <a:tcPr marL="91440" marR="91440" marT="45720" marB="45720" anchor="ctr">
+                  <a:tcPr anchor="ctr">
                     <a:lnL w="6350" cap="flat" cmpd="sng" algn="ctr">
                       <a:solidFill>
                         <a:srgbClr val="DCE6E4"/>
@@ -11203,7 +11454,7 @@
                     <a:bodyPr/>
                     <a:lstStyle/>
                     <a:p>
-                      <a:pPr indent="0" marL="0">
+                      <a:pPr marL="0" indent="0">
                         <a:buNone/>
                       </a:pPr>
                       <a:r>
@@ -11217,7 +11468,7 @@
                       <a:endParaRPr lang="en-US" sz="1200" dirty="0"/>
                     </a:p>
                   </a:txBody>
-                  <a:tcPr marL="91440" marR="91440" marT="45720" marB="45720" anchor="ctr">
+                  <a:tcPr anchor="ctr">
                     <a:lnL w="6350" cap="flat" cmpd="sng" algn="ctr">
                       <a:solidFill>
                         <a:srgbClr val="DCE6E4"/>
@@ -11264,7 +11515,7 @@
                     <a:bodyPr/>
                     <a:lstStyle/>
                     <a:p>
-                      <a:pPr indent="0" marL="0">
+                      <a:pPr marL="0" indent="0">
                         <a:buNone/>
                       </a:pPr>
                       <a:r>
@@ -11278,7 +11529,7 @@
                       <a:endParaRPr lang="en-US" sz="1200" dirty="0"/>
                     </a:p>
                   </a:txBody>
-                  <a:tcPr marL="91440" marR="91440" marT="45720" marB="45720" anchor="ctr">
+                  <a:tcPr anchor="ctr">
                     <a:lnL w="6350" cap="flat" cmpd="sng" algn="ctr">
                       <a:solidFill>
                         <a:srgbClr val="DCE6E4"/>
@@ -11320,6 +11571,11 @@
                     </a:solidFill>
                   </a:tcPr>
                 </a:tc>
+                <a:extLst>
+                  <a:ext uri="{0D108BD9-81ED-4DB2-BD59-A6C34878D82A}">
+                    <a16:rowId xmlns:a16="http://schemas.microsoft.com/office/drawing/2014/main" val="10002"/>
+                  </a:ext>
+                </a:extLst>
               </a:tr>
               <a:tr h="438912">
                 <a:tc>
@@ -11327,7 +11583,7 @@
                     <a:bodyPr/>
                     <a:lstStyle/>
                     <a:p>
-                      <a:pPr indent="0" marL="0">
+                      <a:pPr marL="0" indent="0">
                         <a:buNone/>
                       </a:pPr>
                       <a:r>
@@ -11341,7 +11597,7 @@
                       <a:endParaRPr lang="en-US" sz="1200" dirty="0"/>
                     </a:p>
                   </a:txBody>
-                  <a:tcPr marL="91440" marR="91440" marT="45720" marB="45720" anchor="ctr">
+                  <a:tcPr anchor="ctr">
                     <a:lnL w="6350" cap="flat" cmpd="sng" algn="ctr">
                       <a:solidFill>
                         <a:srgbClr val="DCE6E4"/>
@@ -11388,7 +11644,7 @@
                     <a:bodyPr/>
                     <a:lstStyle/>
                     <a:p>
-                      <a:pPr indent="0" marL="0">
+                      <a:pPr marL="0" indent="0">
                         <a:buNone/>
                       </a:pPr>
                       <a:r>
@@ -11402,7 +11658,7 @@
                       <a:endParaRPr lang="en-US" sz="1200" dirty="0"/>
                     </a:p>
                   </a:txBody>
-                  <a:tcPr marL="91440" marR="91440" marT="45720" marB="45720" anchor="ctr">
+                  <a:tcPr anchor="ctr">
                     <a:lnL w="6350" cap="flat" cmpd="sng" algn="ctr">
                       <a:solidFill>
                         <a:srgbClr val="DCE6E4"/>
@@ -11449,7 +11705,7 @@
                     <a:bodyPr/>
                     <a:lstStyle/>
                     <a:p>
-                      <a:pPr indent="0" marL="0">
+                      <a:pPr marL="0" indent="0">
                         <a:buNone/>
                       </a:pPr>
                       <a:r>
@@ -11463,7 +11719,7 @@
                       <a:endParaRPr lang="en-US" sz="1200" dirty="0"/>
                     </a:p>
                   </a:txBody>
-                  <a:tcPr marL="91440" marR="91440" marT="45720" marB="45720" anchor="ctr">
+                  <a:tcPr anchor="ctr">
                     <a:lnL w="6350" cap="flat" cmpd="sng" algn="ctr">
                       <a:solidFill>
                         <a:srgbClr val="DCE6E4"/>
@@ -11510,7 +11766,7 @@
                     <a:bodyPr/>
                     <a:lstStyle/>
                     <a:p>
-                      <a:pPr indent="0" marL="0">
+                      <a:pPr marL="0" indent="0">
                         <a:buNone/>
                       </a:pPr>
                       <a:r>
@@ -11524,7 +11780,7 @@
                       <a:endParaRPr lang="en-US" sz="1200" dirty="0"/>
                     </a:p>
                   </a:txBody>
-                  <a:tcPr marL="91440" marR="91440" marT="45720" marB="45720" anchor="ctr">
+                  <a:tcPr anchor="ctr">
                     <a:lnL w="6350" cap="flat" cmpd="sng" algn="ctr">
                       <a:solidFill>
                         <a:srgbClr val="DCE6E4"/>
@@ -11566,6 +11822,11 @@
                     </a:solidFill>
                   </a:tcPr>
                 </a:tc>
+                <a:extLst>
+                  <a:ext uri="{0D108BD9-81ED-4DB2-BD59-A6C34878D82A}">
+                    <a16:rowId xmlns:a16="http://schemas.microsoft.com/office/drawing/2014/main" val="10003"/>
+                  </a:ext>
+                </a:extLst>
               </a:tr>
               <a:tr h="438912">
                 <a:tc>
@@ -11573,7 +11834,7 @@
                     <a:bodyPr/>
                     <a:lstStyle/>
                     <a:p>
-                      <a:pPr indent="0" marL="0">
+                      <a:pPr marL="0" indent="0">
                         <a:buNone/>
                       </a:pPr>
                       <a:r>
@@ -11587,7 +11848,7 @@
                       <a:endParaRPr lang="en-US" sz="1200" dirty="0"/>
                     </a:p>
                   </a:txBody>
-                  <a:tcPr marL="91440" marR="91440" marT="45720" marB="45720" anchor="ctr">
+                  <a:tcPr anchor="ctr">
                     <a:lnL w="6350" cap="flat" cmpd="sng" algn="ctr">
                       <a:solidFill>
                         <a:srgbClr val="DCE6E4"/>
@@ -11634,7 +11895,7 @@
                     <a:bodyPr/>
                     <a:lstStyle/>
                     <a:p>
-                      <a:pPr indent="0" marL="0">
+                      <a:pPr marL="0" indent="0">
                         <a:buNone/>
                       </a:pPr>
                       <a:r>
@@ -11648,7 +11909,7 @@
                       <a:endParaRPr lang="en-US" sz="1200" dirty="0"/>
                     </a:p>
                   </a:txBody>
-                  <a:tcPr marL="91440" marR="91440" marT="45720" marB="45720" anchor="ctr">
+                  <a:tcPr anchor="ctr">
                     <a:lnL w="6350" cap="flat" cmpd="sng" algn="ctr">
                       <a:solidFill>
                         <a:srgbClr val="DCE6E4"/>
@@ -11695,7 +11956,7 @@
                     <a:bodyPr/>
                     <a:lstStyle/>
                     <a:p>
-                      <a:pPr indent="0" marL="0">
+                      <a:pPr marL="0" indent="0">
                         <a:buNone/>
                       </a:pPr>
                       <a:r>
@@ -11709,7 +11970,7 @@
                       <a:endParaRPr lang="en-US" sz="1200" dirty="0"/>
                     </a:p>
                   </a:txBody>
-                  <a:tcPr marL="91440" marR="91440" marT="45720" marB="45720" anchor="ctr">
+                  <a:tcPr anchor="ctr">
                     <a:lnL w="6350" cap="flat" cmpd="sng" algn="ctr">
                       <a:solidFill>
                         <a:srgbClr val="DCE6E4"/>
@@ -11756,7 +12017,7 @@
                     <a:bodyPr/>
                     <a:lstStyle/>
                     <a:p>
-                      <a:pPr indent="0" marL="0">
+                      <a:pPr marL="0" indent="0">
                         <a:buNone/>
                       </a:pPr>
                       <a:r>
@@ -11770,7 +12031,7 @@
                       <a:endParaRPr lang="en-US" sz="1200" dirty="0"/>
                     </a:p>
                   </a:txBody>
-                  <a:tcPr marL="91440" marR="91440" marT="45720" marB="45720" anchor="ctr">
+                  <a:tcPr anchor="ctr">
                     <a:lnL w="6350" cap="flat" cmpd="sng" algn="ctr">
                       <a:solidFill>
                         <a:srgbClr val="DCE6E4"/>
@@ -11812,6 +12073,11 @@
                     </a:solidFill>
                   </a:tcPr>
                 </a:tc>
+                <a:extLst>
+                  <a:ext uri="{0D108BD9-81ED-4DB2-BD59-A6C34878D82A}">
+                    <a16:rowId xmlns:a16="http://schemas.microsoft.com/office/drawing/2014/main" val="10004"/>
+                  </a:ext>
+                </a:extLst>
               </a:tr>
             </a:tbl>
           </a:graphicData>
@@ -11843,6 +12109,13 @@
             <a:prstDash val="solid"/>
           </a:ln>
         </p:spPr>
+        <p:txBody>
+          <a:bodyPr/>
+          <a:lstStyle/>
+          <a:p>
+            <a:endParaRPr lang="es-CO"/>
+          </a:p>
+        </p:txBody>
       </p:sp>
       <p:sp>
         <p:nvSpPr>
@@ -11865,7 +12138,7 @@
           <a:bodyPr wrap="square" lIns="0" tIns="0" rIns="0" bIns="0" rtlCol="0" anchor="ctr"/>
           <a:lstStyle/>
           <a:p>
-            <a:pPr indent="0" marL="0">
+            <a:pPr marL="0" indent="0">
               <a:buNone/>
             </a:pPr>
             <a:r>
@@ -11876,9 +12149,6 @@
               </a:rPr>
               <a:t>Lectura: </a:t>
             </a:r>
-            <a:pPr indent="0" marL="0">
-              <a:buNone/>
-            </a:pPr>
             <a:r>
               <a:rPr lang="en-US" sz="1200" dirty="0">
                 <a:solidFill>
@@ -11911,7 +12181,7 @@
           </a:prstGeom>
           <a:extLst>
             <a:ext uri="{C572A759-6A51-4108-AA02-DFA0A04FC94B}">
-              <ma14:wrappingTextBoxFlag xmlns:ma14="http://schemas.microsoft.com/office/mac/drawingml/2011/main" val="0"/>
+              <ma14:wrappingTextBoxFlag xmlns:ma14="http://schemas.microsoft.com/office/mac/drawingml/2011/main" xmlns="" val="0"/>
             </a:ext>
           </a:extLst>
         </p:spPr>
@@ -11929,7 +12199,7 @@
           <a:p>
             <a:pPr algn="r"/>
             <a:fld id="{F7021451-1387-4CA6-816F-3879F97B5CBC}" type="slidenum">
-              <a:rPr b="0" lang="en-US"/>
+              <a:rPr lang="en-US" b="0"/>
               <a:t>8</a:t>
             </a:fld>
             <a:endParaRPr lang="en-US"/>
@@ -11964,9 +12234,11 @@
       <p:sp>
         <p:nvSpPr>
           <p:cNvPr id="2" name="Text 0"/>
-          <p:cNvSpPr/>
+          <p:cNvSpPr>
+            <a:spLocks noGrp="1"/>
+          </p:cNvSpPr>
           <p:nvPr>
-            <p:ph idx="100" type="title" hasCustomPrompt="1"/>
+            <p:ph type="title" idx="100" hasCustomPrompt="1"/>
           </p:nvPr>
         </p:nvSpPr>
         <p:spPr>
@@ -11984,7 +12256,7 @@
           <a:bodyPr wrap="square" lIns="0" tIns="0" rIns="0" bIns="0" rtlCol="0" anchor="ctr"/>
           <a:lstStyle/>
           <a:p>
-            <a:pPr indent="0" marL="0">
+            <a:pPr marL="0" indent="0">
               <a:buNone/>
             </a:pPr>
             <a:r>
@@ -12004,7 +12276,7 @@
       </p:sp>
       <p:graphicFrame>
         <p:nvGraphicFramePr>
-          <p:cNvPr id="3" name="Chart 0" descr=""/>
+          <p:cNvPr id="3" name="Chart 0"/>
           <p:cNvGraphicFramePr/>
           <p:nvPr/>
         </p:nvGraphicFramePr>
@@ -12012,9 +12284,9 @@
           <a:off x="365760" y="1097280"/>
           <a:ext cx="4937760" cy="3474720"/>
         </p:xfrm>
-        <a:graphic xmlns:a="http://schemas.openxmlformats.org/drawingml/2006/main">
+        <a:graphic>
           <a:graphicData uri="http://schemas.openxmlformats.org/drawingml/2006/chart">
-            <c:chart xmlns:c="http://schemas.openxmlformats.org/drawingml/2006/chart" r:id="rId1"/>
+            <c:chart xmlns:c="http://schemas.openxmlformats.org/drawingml/2006/chart" xmlns:r="http://schemas.openxmlformats.org/officeDocument/2006/relationships" r:id="rId3"/>
           </a:graphicData>
         </a:graphic>
       </p:graphicFrame>
@@ -12044,6 +12316,13 @@
             <a:prstDash val="solid"/>
           </a:ln>
         </p:spPr>
+        <p:txBody>
+          <a:bodyPr/>
+          <a:lstStyle/>
+          <a:p>
+            <a:endParaRPr lang="es-CO"/>
+          </a:p>
+        </p:txBody>
       </p:sp>
       <p:sp>
         <p:nvSpPr>
@@ -12066,7 +12345,7 @@
           <a:bodyPr wrap="square" lIns="0" tIns="0" rIns="0" bIns="0" rtlCol="0" anchor="t"/>
           <a:lstStyle/>
           <a:p>
-            <a:pPr indent="0" marL="0">
+            <a:pPr marL="0" indent="0">
               <a:buNone/>
             </a:pPr>
             <a:r>
@@ -12105,7 +12384,7 @@
           <a:bodyPr wrap="square" lIns="0" tIns="0" rIns="0" bIns="0" rtlCol="0" anchor="t"/>
           <a:lstStyle/>
           <a:p>
-            <a:pPr indent="0" marL="0">
+            <a:pPr marL="0" indent="0">
               <a:buNone/>
             </a:pPr>
             <a:r>
@@ -12141,7 +12420,7 @@
           <a:bodyPr wrap="square" lIns="0" tIns="0" rIns="0" bIns="0" rtlCol="0" anchor="t"/>
           <a:lstStyle/>
           <a:p>
-            <a:pPr indent="0" marL="0">
+            <a:pPr marL="0" indent="0">
               <a:buNone/>
             </a:pPr>
             <a:r>
@@ -12180,7 +12459,7 @@
           <a:bodyPr wrap="square" lIns="0" tIns="0" rIns="0" bIns="0" rtlCol="0" anchor="t"/>
           <a:lstStyle/>
           <a:p>
-            <a:pPr indent="0" marL="0">
+            <a:pPr marL="0" indent="0">
               <a:buNone/>
             </a:pPr>
             <a:r>
@@ -12216,7 +12495,7 @@
           <a:bodyPr wrap="square" lIns="0" tIns="0" rIns="0" bIns="0" rtlCol="0" anchor="t"/>
           <a:lstStyle/>
           <a:p>
-            <a:pPr indent="0" marL="0">
+            <a:pPr marL="0" indent="0">
               <a:buNone/>
             </a:pPr>
             <a:r>
@@ -12255,7 +12534,7 @@
           <a:bodyPr wrap="square" lIns="0" tIns="0" rIns="0" bIns="0" rtlCol="0" anchor="t"/>
           <a:lstStyle/>
           <a:p>
-            <a:pPr indent="0" marL="0">
+            <a:pPr marL="0" indent="0">
               <a:buNone/>
             </a:pPr>
             <a:r>
@@ -12291,7 +12570,7 @@
           <a:bodyPr wrap="square" lIns="0" tIns="0" rIns="0" bIns="0" rtlCol="0" anchor="t"/>
           <a:lstStyle/>
           <a:p>
-            <a:pPr indent="0" marL="0">
+            <a:pPr marL="0" indent="0">
               <a:buNone/>
             </a:pPr>
             <a:r>
@@ -12326,7 +12605,7 @@
           </a:prstGeom>
           <a:extLst>
             <a:ext uri="{C572A759-6A51-4108-AA02-DFA0A04FC94B}">
-              <ma14:wrappingTextBoxFlag xmlns:ma14="http://schemas.microsoft.com/office/mac/drawingml/2011/main" val="0"/>
+              <ma14:wrappingTextBoxFlag xmlns:ma14="http://schemas.microsoft.com/office/mac/drawingml/2011/main" xmlns="" val="0"/>
             </a:ext>
           </a:extLst>
         </p:spPr>
@@ -12344,7 +12623,7 @@
           <a:p>
             <a:pPr algn="r"/>
             <a:fld id="{F7021451-1387-4CA6-816F-3879F97B5CBC}" type="slidenum">
-              <a:rPr b="0" lang="en-US"/>
+              <a:rPr lang="en-US" b="0"/>
               <a:t>9</a:t>
             </a:fld>
             <a:endParaRPr lang="en-US"/>
@@ -12652,4 +12931,319 @@
     </a:ext>
   </a:extLst>
 </a:theme>
+</file>
+
+<file path=ppt/theme/theme2.xml><?xml version="1.0" encoding="utf-8"?>
+<a:theme xmlns:a="http://schemas.openxmlformats.org/drawingml/2006/main" name="Tema de Office">
+  <a:themeElements>
+    <a:clrScheme name="Office">
+      <a:dk1>
+        <a:sysClr val="windowText" lastClr="000000"/>
+      </a:dk1>
+      <a:lt1>
+        <a:sysClr val="window" lastClr="FFFFFF"/>
+      </a:lt1>
+      <a:dk2>
+        <a:srgbClr val="0E2841"/>
+      </a:dk2>
+      <a:lt2>
+        <a:srgbClr val="E8E8E8"/>
+      </a:lt2>
+      <a:accent1>
+        <a:srgbClr val="156082"/>
+      </a:accent1>
+      <a:accent2>
+        <a:srgbClr val="E97132"/>
+      </a:accent2>
+      <a:accent3>
+        <a:srgbClr val="196B24"/>
+      </a:accent3>
+      <a:accent4>
+        <a:srgbClr val="0F9ED5"/>
+      </a:accent4>
+      <a:accent5>
+        <a:srgbClr val="A02B93"/>
+      </a:accent5>
+      <a:accent6>
+        <a:srgbClr val="4EA72E"/>
+      </a:accent6>
+      <a:hlink>
+        <a:srgbClr val="467886"/>
+      </a:hlink>
+      <a:folHlink>
+        <a:srgbClr val="96607D"/>
+      </a:folHlink>
+    </a:clrScheme>
+    <a:fontScheme name="Office">
+      <a:majorFont>
+        <a:latin typeface="Aptos Display" panose="02110004020202020204"/>
+        <a:ea typeface=""/>
+        <a:cs typeface=""/>
+        <a:font script="Jpan" typeface="游ゴシック Light"/>
+        <a:font script="Hang" typeface="맑은 고딕"/>
+        <a:font script="Hans" typeface="等线 Light"/>
+        <a:font script="Hant" typeface="新細明體"/>
+        <a:font script="Arab" typeface="Times New Roman"/>
+        <a:font script="Hebr" typeface="Times New Roman"/>
+        <a:font script="Thai" typeface="Angsana New"/>
+        <a:font script="Ethi" typeface="Nyala"/>
+        <a:font script="Beng" typeface="Vrinda"/>
+        <a:font script="Gujr" typeface="Shruti"/>
+        <a:font script="Khmr" typeface="MoolBoran"/>
+        <a:font script="Knda" typeface="Tunga"/>
+        <a:font script="Guru" typeface="Raavi"/>
+        <a:font script="Cans" typeface="Euphemia"/>
+        <a:font script="Cher" typeface="Plantagenet Cherokee"/>
+        <a:font script="Yiii" typeface="Microsoft Yi Baiti"/>
+        <a:font script="Tibt" typeface="Microsoft Himalaya"/>
+        <a:font script="Thaa" typeface="MV Boli"/>
+        <a:font script="Deva" typeface="Mangal"/>
+        <a:font script="Telu" typeface="Gautami"/>
+        <a:font script="Taml" typeface="Latha"/>
+        <a:font script="Syrc" typeface="Estrangelo Edessa"/>
+        <a:font script="Orya" typeface="Kalinga"/>
+        <a:font script="Mlym" typeface="Kartika"/>
+        <a:font script="Laoo" typeface="DokChampa"/>
+        <a:font script="Sinh" typeface="Iskoola Pota"/>
+        <a:font script="Mong" typeface="Mongolian Baiti"/>
+        <a:font script="Viet" typeface="Times New Roman"/>
+        <a:font script="Uigh" typeface="Microsoft Uighur"/>
+        <a:font script="Geor" typeface="Sylfaen"/>
+        <a:font script="Armn" typeface="Arial"/>
+        <a:font script="Bugi" typeface="Leelawadee UI"/>
+        <a:font script="Bopo" typeface="Microsoft JhengHei"/>
+        <a:font script="Java" typeface="Javanese Text"/>
+        <a:font script="Lisu" typeface="Segoe UI"/>
+        <a:font script="Mymr" typeface="Myanmar Text"/>
+        <a:font script="Nkoo" typeface="Ebrima"/>
+        <a:font script="Olck" typeface="Nirmala UI"/>
+        <a:font script="Osma" typeface="Ebrima"/>
+        <a:font script="Phag" typeface="Phagspa"/>
+        <a:font script="Syrn" typeface="Estrangelo Edessa"/>
+        <a:font script="Syrj" typeface="Estrangelo Edessa"/>
+        <a:font script="Syre" typeface="Estrangelo Edessa"/>
+        <a:font script="Sora" typeface="Nirmala UI"/>
+        <a:font script="Tale" typeface="Microsoft Tai Le"/>
+        <a:font script="Talu" typeface="Microsoft New Tai Lue"/>
+        <a:font script="Tfng" typeface="Ebrima"/>
+      </a:majorFont>
+      <a:minorFont>
+        <a:latin typeface="Aptos" panose="02110004020202020204"/>
+        <a:ea typeface=""/>
+        <a:cs typeface=""/>
+        <a:font script="Jpan" typeface="游ゴシック"/>
+        <a:font script="Hang" typeface="맑은 고딕"/>
+        <a:font script="Hans" typeface="等线"/>
+        <a:font script="Hant" typeface="新細明體"/>
+        <a:font script="Arab" typeface="Arial"/>
+        <a:font script="Hebr" typeface="Arial"/>
+        <a:font script="Thai" typeface="Cordia New"/>
+        <a:font script="Ethi" typeface="Nyala"/>
+        <a:font script="Beng" typeface="Vrinda"/>
+        <a:font script="Gujr" typeface="Shruti"/>
+        <a:font script="Khmr" typeface="DaunPenh"/>
+        <a:font script="Knda" typeface="Tunga"/>
+        <a:font script="Guru" typeface="Raavi"/>
+        <a:font script="Cans" typeface="Euphemia"/>
+        <a:font script="Cher" typeface="Plantagenet Cherokee"/>
+        <a:font script="Yiii" typeface="Microsoft Yi Baiti"/>
+        <a:font script="Tibt" typeface="Microsoft Himalaya"/>
+        <a:font script="Thaa" typeface="MV Boli"/>
+        <a:font script="Deva" typeface="Mangal"/>
+        <a:font script="Telu" typeface="Gautami"/>
+        <a:font script="Taml" typeface="Latha"/>
+        <a:font script="Syrc" typeface="Estrangelo Edessa"/>
+        <a:font script="Orya" typeface="Kalinga"/>
+        <a:font script="Mlym" typeface="Kartika"/>
+        <a:font script="Laoo" typeface="DokChampa"/>
+        <a:font script="Sinh" typeface="Iskoola Pota"/>
+        <a:font script="Mong" typeface="Mongolian Baiti"/>
+        <a:font script="Viet" typeface="Arial"/>
+        <a:font script="Uigh" typeface="Microsoft Uighur"/>
+        <a:font script="Geor" typeface="Sylfaen"/>
+        <a:font script="Armn" typeface="Arial"/>
+        <a:font script="Bugi" typeface="Leelawadee UI"/>
+        <a:font script="Bopo" typeface="Microsoft JhengHei"/>
+        <a:font script="Java" typeface="Javanese Text"/>
+        <a:font script="Lisu" typeface="Segoe UI"/>
+        <a:font script="Mymr" typeface="Myanmar Text"/>
+        <a:font script="Nkoo" typeface="Ebrima"/>
+        <a:font script="Olck" typeface="Nirmala UI"/>
+        <a:font script="Osma" typeface="Ebrima"/>
+        <a:font script="Phag" typeface="Phagspa"/>
+        <a:font script="Syrn" typeface="Estrangelo Edessa"/>
+        <a:font script="Syrj" typeface="Estrangelo Edessa"/>
+        <a:font script="Syre" typeface="Estrangelo Edessa"/>
+        <a:font script="Sora" typeface="Nirmala UI"/>
+        <a:font script="Tale" typeface="Microsoft Tai Le"/>
+        <a:font script="Talu" typeface="Microsoft New Tai Lue"/>
+        <a:font script="Tfng" typeface="Ebrima"/>
+      </a:minorFont>
+    </a:fontScheme>
+    <a:fmtScheme name="Office">
+      <a:fillStyleLst>
+        <a:solidFill>
+          <a:schemeClr val="phClr"/>
+        </a:solidFill>
+        <a:gradFill rotWithShape="1">
+          <a:gsLst>
+            <a:gs pos="0">
+              <a:schemeClr val="phClr">
+                <a:lumMod val="110000"/>
+                <a:satMod val="105000"/>
+                <a:tint val="67000"/>
+              </a:schemeClr>
+            </a:gs>
+            <a:gs pos="50000">
+              <a:schemeClr val="phClr">
+                <a:lumMod val="105000"/>
+                <a:satMod val="103000"/>
+                <a:tint val="73000"/>
+              </a:schemeClr>
+            </a:gs>
+            <a:gs pos="100000">
+              <a:schemeClr val="phClr">
+                <a:lumMod val="105000"/>
+                <a:satMod val="109000"/>
+                <a:tint val="81000"/>
+              </a:schemeClr>
+            </a:gs>
+          </a:gsLst>
+          <a:lin ang="5400000" scaled="0"/>
+        </a:gradFill>
+        <a:gradFill rotWithShape="1">
+          <a:gsLst>
+            <a:gs pos="0">
+              <a:schemeClr val="phClr">
+                <a:satMod val="103000"/>
+                <a:lumMod val="102000"/>
+                <a:tint val="94000"/>
+              </a:schemeClr>
+            </a:gs>
+            <a:gs pos="50000">
+              <a:schemeClr val="phClr">
+                <a:satMod val="110000"/>
+                <a:lumMod val="100000"/>
+                <a:shade val="100000"/>
+              </a:schemeClr>
+            </a:gs>
+            <a:gs pos="100000">
+              <a:schemeClr val="phClr">
+                <a:lumMod val="99000"/>
+                <a:satMod val="120000"/>
+                <a:shade val="78000"/>
+              </a:schemeClr>
+            </a:gs>
+          </a:gsLst>
+          <a:lin ang="5400000" scaled="0"/>
+        </a:gradFill>
+      </a:fillStyleLst>
+      <a:lnStyleLst>
+        <a:ln w="12700" cap="flat" cmpd="sng" algn="ctr">
+          <a:solidFill>
+            <a:schemeClr val="phClr"/>
+          </a:solidFill>
+          <a:prstDash val="solid"/>
+          <a:miter lim="800000"/>
+        </a:ln>
+        <a:ln w="19050" cap="flat" cmpd="sng" algn="ctr">
+          <a:solidFill>
+            <a:schemeClr val="phClr"/>
+          </a:solidFill>
+          <a:prstDash val="solid"/>
+          <a:miter lim="800000"/>
+        </a:ln>
+        <a:ln w="25400" cap="flat" cmpd="sng" algn="ctr">
+          <a:solidFill>
+            <a:schemeClr val="phClr"/>
+          </a:solidFill>
+          <a:prstDash val="solid"/>
+          <a:miter lim="800000"/>
+        </a:ln>
+      </a:lnStyleLst>
+      <a:effectStyleLst>
+        <a:effectStyle>
+          <a:effectLst/>
+        </a:effectStyle>
+        <a:effectStyle>
+          <a:effectLst/>
+        </a:effectStyle>
+        <a:effectStyle>
+          <a:effectLst>
+            <a:outerShdw blurRad="57150" dist="19050" dir="5400000" algn="ctr" rotWithShape="0">
+              <a:srgbClr val="000000">
+                <a:alpha val="63000"/>
+              </a:srgbClr>
+            </a:outerShdw>
+          </a:effectLst>
+        </a:effectStyle>
+      </a:effectStyleLst>
+      <a:bgFillStyleLst>
+        <a:solidFill>
+          <a:schemeClr val="phClr"/>
+        </a:solidFill>
+        <a:solidFill>
+          <a:schemeClr val="phClr">
+            <a:tint val="95000"/>
+            <a:satMod val="170000"/>
+          </a:schemeClr>
+        </a:solidFill>
+        <a:gradFill rotWithShape="1">
+          <a:gsLst>
+            <a:gs pos="0">
+              <a:schemeClr val="phClr">
+                <a:tint val="93000"/>
+                <a:satMod val="150000"/>
+                <a:shade val="98000"/>
+                <a:lumMod val="102000"/>
+              </a:schemeClr>
+            </a:gs>
+            <a:gs pos="50000">
+              <a:schemeClr val="phClr">
+                <a:tint val="98000"/>
+                <a:satMod val="130000"/>
+                <a:shade val="90000"/>
+                <a:lumMod val="103000"/>
+              </a:schemeClr>
+            </a:gs>
+            <a:gs pos="100000">
+              <a:schemeClr val="phClr">
+                <a:shade val="63000"/>
+                <a:satMod val="120000"/>
+              </a:schemeClr>
+            </a:gs>
+          </a:gsLst>
+          <a:lin ang="5400000" scaled="0"/>
+        </a:gradFill>
+      </a:bgFillStyleLst>
+    </a:fmtScheme>
+  </a:themeElements>
+  <a:objectDefaults>
+    <a:lnDef>
+      <a:spPr/>
+      <a:bodyPr/>
+      <a:lstStyle/>
+      <a:style>
+        <a:lnRef idx="2">
+          <a:schemeClr val="accent1"/>
+        </a:lnRef>
+        <a:fillRef idx="0">
+          <a:schemeClr val="accent1"/>
+        </a:fillRef>
+        <a:effectRef idx="1">
+          <a:schemeClr val="accent1"/>
+        </a:effectRef>
+        <a:fontRef idx="minor">
+          <a:schemeClr val="tx1"/>
+        </a:fontRef>
+      </a:style>
+    </a:lnDef>
+  </a:objectDefaults>
+  <a:extraClrSchemeLst/>
+  <a:extLst>
+    <a:ext uri="{05A4C25C-085E-4340-85A3-A5531E510DB2}">
+      <thm15:themeFamily xmlns:thm15="http://schemas.microsoft.com/office/thememl/2012/main" name="Office Theme" id="{2E142A2C-CD16-42D6-873A-C26D2A0506FA}" vid="{1BDDFF52-6CD6-40A5-AB3C-68EB2F1E4D0A}"/>
+    </a:ext>
+  </a:extLst>
+</a:theme>
 </file>
</xml_diff>

<commit_message>
Ronda 26: PPT refleja documentos digitalizados y verificación automatizada
- Lámina 12: TEC-05 (código y pruebas) pasa a Completado, 48 pruebas.
- Nota inferior: documentos digitalizados y verificación automatizada con Camunda.
- Lámina 11: la leyenda ámbar ya no dice que falta el código.

Co-Authored-By: Claude Sonnet 5 <noreply@anthropic.com>
</commit_message>
<xml_diff>
--- a/trabajos/mi-proceso/Automatización PPT.pptx
+++ b/trabajos/mi-proceso/Automatización PPT.pptx
@@ -4942,7 +4942,7 @@
                   <a:schemeClr val="tx1"/>
                 </a:solidFill>
               </a:rPr>
-              <a:t>en curso (código y despliegue a cargo del equipo técnico)</a:t>
+              <a:t>en curso (despliegue a cargo del equipo técnico; código ya hecho)</a:t>
             </a:r>
             <a:endParaRPr lang="en-US" sz="1100" dirty="0"/>
           </a:p>
@@ -5953,7 +5953,7 @@
                             <a:schemeClr val="tx1"/>
                           </a:solidFill>
                         </a:rPr>
-                        <a:t>Código y 43 pruebas (TEC-05)</a:t>
+                        <a:t>Código y 48 pruebas (TEC-05)</a:t>
                       </a:r>
                       <a:endParaRPr lang="en-US" sz="1100" dirty="0"/>
                     </a:p>
@@ -6011,7 +6011,7 @@
                             <a:schemeClr val="tx1"/>
                           </a:solidFill>
                         </a:rPr>
-                        <a:t>Sin iniciar</a:t>
+                        <a:t>Completado</a:t>
                       </a:r>
                       <a:endParaRPr lang="en-US" sz="1100" dirty="0"/>
                     </a:p>
@@ -6095,7 +6095,7 @@
                   <a:schemeClr val="tx2"/>
                 </a:solidFill>
               </a:rPr>
-              <a:t>Responsables: David y Sergio. Backlog siguiente: INC-1 estado al cliente → INC-2 cierre a 10 días → INC-3 recordatorios.</a:t>
+              <a:t>Hecho: documentos digitalizados; verificación automatizada con Camunda. David y Sergio hacen el despliegue. Backlog: INC-1 estado al cliente → INC-2 cierre a 10 días → INC-3 recordatorios.</a:t>
             </a:r>
             <a:endParaRPr lang="en-US" sz="1100" dirty="0"/>
           </a:p>

</xml_diff>